<commit_message>
Presentation v2: fixes from two independent evaluations
Slide 6 rebuilt verbatim from current RAG evidence (1,791 products, real per-stage table, 14pt); slide 3 strip RTL corrected; trainer credited on title slide; idempotency and no-mocks wording made precise; whitespace/screenshot-size/italics/closing-message polish. Co-Authored-By: Claude Fable 5 <noreply@anthropic.com>
</commit_message>
<xml_diff>
--- a/docs/presentation.pptx
+++ b/docs/presentation.pptx
@@ -776,7 +776,8 @@
           <a:p>
             <a:r>
               <a:rPr lang="en-US" dirty="0"/>
-              <a:t>اخترنا بيانات UCI الحقيقية عمداً: عيوبها الحقيقية (فقدان، سوالب، تكرارات) هي التي تختبر بوابات الجودة ومسارات الفشل بصدق.</a:t>
+              <a:t>اخترنا بيانات UCI الحقيقية عمداً: عيوبها الحقيقية (فقدان، سوالب، تكرارات) هي التي تختبر بوابات الجودة ومسارات الفشل بصدق.
+Citation: Chen, D. (2015). Online Retail. UCI ML Repository. doi:10.24432/C5BW33</a:t>
             </a:r>
             <a:endParaRPr lang="en-US" dirty="0"/>
           </a:p>
@@ -2271,7 +2272,7 @@
         </p:nvSpPr>
         <p:spPr>
           <a:xfrm>
-            <a:off x="731520" y="5074920"/>
+            <a:off x="731520" y="4892040"/>
             <a:ext cx="10728655" cy="411480"/>
           </a:xfrm>
           <a:prstGeom prst="rect">
@@ -2310,7 +2311,46 @@
         </p:nvSpPr>
         <p:spPr>
           <a:xfrm>
-            <a:off x="731520" y="5504688"/>
+            <a:off x="731520" y="5321808"/>
+            <a:ext cx="10728655" cy="365760"/>
+          </a:xfrm>
+          <a:prstGeom prst="rect">
+            <a:avLst/>
+          </a:prstGeom>
+          <a:noFill/>
+          <a:ln/>
+        </p:spPr>
+        <p:txBody>
+          <a:bodyPr wrap="square" lIns="0" tIns="0" rIns="0" bIns="0" rtlCol="0" anchor="ctr"/>
+          <a:lstStyle/>
+          <a:p>
+            <a:pPr rtl="1" algn="ctr" indent="0" marL="0">
+              <a:buNone/>
+            </a:pPr>
+            <a:r>
+              <a:rPr lang="en-US" sz="1400" dirty="0">
+                <a:solidFill>
+                  <a:srgbClr val="CDE4E0"/>
+                </a:solidFill>
+                <a:latin typeface="Arial" pitchFamily="34" charset="0"/>
+                <a:ea typeface="Arial" pitchFamily="34" charset="-122"/>
+                <a:cs typeface="Arial" pitchFamily="34" charset="-120"/>
+              </a:rPr>
+              <a:t>المدرب ‏Mohammed Albeladi‏ —‏ محمد البلادي</a:t>
+            </a:r>
+            <a:endParaRPr lang="en-US" sz="1400" dirty="0"/>
+          </a:p>
+        </p:txBody>
+      </p:sp>
+      <p:sp>
+        <p:nvSpPr>
+          <p:cNvPr id="18" name="Text 16"/>
+          <p:cNvSpPr/>
+          <p:nvPr/>
+        </p:nvSpPr>
+        <p:spPr>
+          <a:xfrm>
+            <a:off x="731520" y="5733288"/>
             <a:ext cx="10728655" cy="365760"/>
           </a:xfrm>
           <a:prstGeom prst="rect">
@@ -2488,7 +2528,7 @@
               <a:buNone/>
             </a:pPr>
             <a:r>
-              <a:rPr lang="en-US" sz="1150" i="1" dirty="0">
+              <a:rPr lang="en-US" sz="1150" dirty="0">
                 <a:solidFill>
                   <a:srgbClr val="5B7176"/>
                 </a:solidFill>
@@ -2916,7 +2956,7 @@
                 <a:ea typeface="Arial" pitchFamily="34" charset="-122"/>
                 <a:cs typeface="Arial" pitchFamily="34" charset="-120"/>
               </a:rPr>
-              <a:t>مكتبات حقيقية، صفر محاكاة</a:t>
+              <a:t>مكونات حقيقية بلا ‏mocks‏ —‏ تدفق الأحداث يُعاد بثه من بيانات حقيقية</a:t>
             </a:r>
             <a:endParaRPr lang="en-US" sz="1350" dirty="0"/>
           </a:p>
@@ -2979,7 +3019,7 @@
               <a:buNone/>
             </a:pPr>
             <a:r>
-              <a:rPr lang="en-US" sz="5400" b="1" dirty="0">
+              <a:rPr lang="en-US" sz="3200" b="1" dirty="0">
                 <a:solidFill>
                   <a:srgbClr val="FFFFFF"/>
                 </a:solidFill>
@@ -2987,9 +3027,9 @@
                 <a:ea typeface="Arial" pitchFamily="34" charset="-122"/>
                 <a:cs typeface="Arial" pitchFamily="34" charset="-120"/>
               </a:rPr>
-              <a:t>شكراً لكم</a:t>
-            </a:r>
-            <a:endParaRPr lang="en-US" sz="5400" dirty="0"/>
+              <a:t>خمسة متطلبات، خمسة أدلة، وأنبوب ينجح ويفشل بصدق</a:t>
+            </a:r>
+            <a:endParaRPr lang="en-US" sz="3200" dirty="0"/>
           </a:p>
         </p:txBody>
       </p:sp>
@@ -4827,7 +4867,7 @@
           <a:bodyPr wrap="square" lIns="0" tIns="0" rIns="0" bIns="0" rtlCol="0" anchor="ctr"/>
           <a:lstStyle/>
           <a:p>
-            <a:pPr algn="ctr" indent="0" marL="0">
+            <a:pPr rtl="1" algn="ctr" indent="0" marL="0">
               <a:buNone/>
             </a:pPr>
             <a:r>
@@ -4855,7 +4895,7 @@
               </a:rPr>
               <a:t> ينسّق عشر مهام بالترتيب   ·   </a:t>
             </a:r>
-            <a:pPr algn="ctr" indent="0" marL="0">
+            <a:pPr rtl="1" algn="ctr" indent="0" marL="0">
               <a:buNone/>
             </a:pPr>
             <a:r>
@@ -5192,12 +5232,12 @@
         </p:nvSpPr>
         <p:spPr>
           <a:xfrm>
-            <a:off x="3017520" y="1691640"/>
-            <a:ext cx="2377440" cy="1828800"/>
+            <a:off x="3017520" y="1600200"/>
+            <a:ext cx="2377440" cy="2514600"/>
           </a:xfrm>
           <a:prstGeom prst="roundRect">
             <a:avLst>
-              <a:gd name="adj" fmla="val 4500"/>
+              <a:gd name="adj" fmla="val 3462"/>
             </a:avLst>
           </a:prstGeom>
           <a:solidFill>
@@ -5219,8 +5259,8 @@
         </p:nvSpPr>
         <p:spPr>
           <a:xfrm>
-            <a:off x="3017520" y="1819656"/>
-            <a:ext cx="2377440" cy="950976"/>
+            <a:off x="3017520" y="1728216"/>
+            <a:ext cx="2377440" cy="1307592"/>
           </a:xfrm>
           <a:prstGeom prst="rect">
             <a:avLst/>
@@ -5258,8 +5298,8 @@
         </p:nvSpPr>
         <p:spPr>
           <a:xfrm>
-            <a:off x="3127248" y="2752344"/>
-            <a:ext cx="2157984" cy="694944"/>
+            <a:off x="3127248" y="3058668"/>
+            <a:ext cx="2157984" cy="955548"/>
           </a:xfrm>
           <a:prstGeom prst="rect">
             <a:avLst/>
@@ -5297,12 +5337,12 @@
         </p:nvSpPr>
         <p:spPr>
           <a:xfrm>
-            <a:off x="548640" y="1691640"/>
-            <a:ext cx="2377440" cy="1828800"/>
+            <a:off x="548640" y="1600200"/>
+            <a:ext cx="2377440" cy="2514600"/>
           </a:xfrm>
           <a:prstGeom prst="roundRect">
             <a:avLst>
-              <a:gd name="adj" fmla="val 4500"/>
+              <a:gd name="adj" fmla="val 3462"/>
             </a:avLst>
           </a:prstGeom>
           <a:solidFill>
@@ -5324,8 +5364,8 @@
         </p:nvSpPr>
         <p:spPr>
           <a:xfrm>
-            <a:off x="548640" y="1819656"/>
-            <a:ext cx="2377440" cy="950976"/>
+            <a:off x="548640" y="1728216"/>
+            <a:ext cx="2377440" cy="1307592"/>
           </a:xfrm>
           <a:prstGeom prst="rect">
             <a:avLst/>
@@ -5363,8 +5403,8 @@
         </p:nvSpPr>
         <p:spPr>
           <a:xfrm>
-            <a:off x="658368" y="2752344"/>
-            <a:ext cx="2157984" cy="694944"/>
+            <a:off x="658368" y="3058668"/>
+            <a:ext cx="2157984" cy="955548"/>
           </a:xfrm>
           <a:prstGeom prst="rect">
             <a:avLst/>
@@ -5402,7 +5442,7 @@
         </p:nvSpPr>
         <p:spPr>
           <a:xfrm>
-            <a:off x="548640" y="3794760"/>
+            <a:off x="548640" y="4343400"/>
             <a:ext cx="4846320" cy="731520"/>
           </a:xfrm>
           <a:prstGeom prst="rect">
@@ -5419,7 +5459,7 @@
               <a:buNone/>
             </a:pPr>
             <a:r>
-              <a:rPr lang="en-US" sz="1350" i="1" dirty="0">
+              <a:rPr lang="en-US" sz="1400" dirty="0">
                 <a:solidFill>
                   <a:srgbClr val="5B7176"/>
                 </a:solidFill>
@@ -5427,9 +5467,9 @@
                 <a:ea typeface="Arial" pitchFamily="34" charset="-122"/>
                 <a:cs typeface="Arial" pitchFamily="34" charset="-120"/>
               </a:rPr>
-              <a:t>لا إسقاط صامت: الأنبوب يستمر والمرفوض محفوظ بدليله</a:t>
-            </a:r>
-            <a:endParaRPr lang="en-US" sz="1350" dirty="0"/>
+              <a:t>لا إسقاط صامت —‏ الأنبوب يستمر والمرفوض محفوظ بدليله</a:t>
+            </a:r>
+            <a:endParaRPr lang="en-US" sz="1400" dirty="0"/>
           </a:p>
         </p:txBody>
       </p:sp>
@@ -5783,7 +5823,7 @@
                 <a:ea typeface="Arial" pitchFamily="34" charset="-122"/>
                 <a:cs typeface="Arial" pitchFamily="34" charset="-120"/>
               </a:rPr>
-              <a:t>إعادة التشغيل آمنة، العملية اتّساقية ‏idempotent</a:t>
+              <a:t>إعادة إرسال نفس مفاتيح العمل آمنة — ‏MERGE‏ يحدّثها ولا يكرّرها</a:t>
             </a:r>
             <a:endParaRPr lang="en-US" sz="1700" dirty="0"/>
           </a:p>
@@ -5818,12 +5858,12 @@
         </p:nvSpPr>
         <p:spPr>
           <a:xfrm>
-            <a:off x="3017520" y="1691640"/>
-            <a:ext cx="2377440" cy="1828800"/>
+            <a:off x="3017520" y="1600200"/>
+            <a:ext cx="2377440" cy="2514600"/>
           </a:xfrm>
           <a:prstGeom prst="roundRect">
             <a:avLst>
-              <a:gd name="adj" fmla="val 4500"/>
+              <a:gd name="adj" fmla="val 3462"/>
             </a:avLst>
           </a:prstGeom>
           <a:solidFill>
@@ -5845,8 +5885,8 @@
         </p:nvSpPr>
         <p:spPr>
           <a:xfrm>
-            <a:off x="3017520" y="1819656"/>
-            <a:ext cx="2377440" cy="950976"/>
+            <a:off x="3017520" y="1728216"/>
+            <a:ext cx="2377440" cy="1307592"/>
           </a:xfrm>
           <a:prstGeom prst="rect">
             <a:avLst/>
@@ -5884,8 +5924,8 @@
         </p:nvSpPr>
         <p:spPr>
           <a:xfrm>
-            <a:off x="3127248" y="2752344"/>
-            <a:ext cx="2157984" cy="694944"/>
+            <a:off x="3127248" y="3058668"/>
+            <a:ext cx="2157984" cy="955548"/>
           </a:xfrm>
           <a:prstGeom prst="rect">
             <a:avLst/>
@@ -5923,12 +5963,12 @@
         </p:nvSpPr>
         <p:spPr>
           <a:xfrm>
-            <a:off x="548640" y="1691640"/>
-            <a:ext cx="2377440" cy="1828800"/>
+            <a:off x="548640" y="1600200"/>
+            <a:ext cx="2377440" cy="2514600"/>
           </a:xfrm>
           <a:prstGeom prst="roundRect">
             <a:avLst>
-              <a:gd name="adj" fmla="val 4500"/>
+              <a:gd name="adj" fmla="val 3462"/>
             </a:avLst>
           </a:prstGeom>
           <a:solidFill>
@@ -5950,8 +5990,8 @@
         </p:nvSpPr>
         <p:spPr>
           <a:xfrm>
-            <a:off x="548640" y="1819656"/>
-            <a:ext cx="2377440" cy="950976"/>
+            <a:off x="548640" y="1728216"/>
+            <a:ext cx="2377440" cy="1307592"/>
           </a:xfrm>
           <a:prstGeom prst="rect">
             <a:avLst/>
@@ -5989,8 +6029,8 @@
         </p:nvSpPr>
         <p:spPr>
           <a:xfrm>
-            <a:off x="658368" y="2752344"/>
-            <a:ext cx="2157984" cy="694944"/>
+            <a:off x="658368" y="3058668"/>
+            <a:ext cx="2157984" cy="955548"/>
           </a:xfrm>
           <a:prstGeom prst="rect">
             <a:avLst/>
@@ -6028,7 +6068,7 @@
         </p:nvSpPr>
         <p:spPr>
           <a:xfrm>
-            <a:off x="548640" y="3794760"/>
+            <a:off x="548640" y="4343400"/>
             <a:ext cx="4846320" cy="731520"/>
           </a:xfrm>
           <a:prstGeom prst="rect">
@@ -6045,7 +6085,7 @@
               <a:buNone/>
             </a:pPr>
             <a:r>
-              <a:rPr lang="en-US" sz="1350" i="1" dirty="0">
+              <a:rPr lang="en-US" sz="1400" dirty="0">
                 <a:solidFill>
                   <a:srgbClr val="5B7176"/>
                 </a:solidFill>
@@ -6055,7 +6095,7 @@
               </a:rPr>
               <a:t>كلاهما في عملية ‏MERGE‏ ذرّية ‏atomic‏ واحدة، وسجل المعاملات شاهد</a:t>
             </a:r>
-            <a:endParaRPr lang="en-US" sz="1350" dirty="0"/>
+            <a:endParaRPr lang="en-US" sz="1400" dirty="0"/>
           </a:p>
         </p:txBody>
       </p:sp>
@@ -6179,7 +6219,7 @@
         </p:nvSpPr>
         <p:spPr>
           <a:xfrm>
-            <a:off x="11076127" y="384048"/>
+            <a:off x="11076127" y="566928"/>
             <a:ext cx="566928" cy="566928"/>
           </a:xfrm>
           <a:prstGeom prst="ellipse">
@@ -6199,7 +6239,7 @@
         </p:nvSpPr>
         <p:spPr>
           <a:xfrm>
-            <a:off x="11076127" y="384048"/>
+            <a:off x="11076127" y="566928"/>
             <a:ext cx="566928" cy="566928"/>
           </a:xfrm>
           <a:prstGeom prst="rect">
@@ -6238,7 +6278,7 @@
         </p:nvSpPr>
         <p:spPr>
           <a:xfrm>
-            <a:off x="548640" y="347472"/>
+            <a:off x="548640" y="530352"/>
             <a:ext cx="10362895" cy="685800"/>
           </a:xfrm>
           <a:prstGeom prst="rect">
@@ -6277,7 +6317,7 @@
         </p:nvSpPr>
         <p:spPr>
           <a:xfrm>
-            <a:off x="548640" y="429768"/>
+            <a:off x="548640" y="612648"/>
             <a:ext cx="1600200" cy="475488"/>
           </a:xfrm>
           <a:prstGeom prst="roundRect">
@@ -6299,7 +6339,7 @@
         </p:nvSpPr>
         <p:spPr>
           <a:xfrm>
-            <a:off x="548640" y="429768"/>
+            <a:off x="548640" y="612648"/>
             <a:ext cx="1600200" cy="475488"/>
           </a:xfrm>
           <a:prstGeom prst="rect">
@@ -6338,7 +6378,7 @@
         </p:nvSpPr>
         <p:spPr>
           <a:xfrm>
-            <a:off x="554584" y="1417320"/>
+            <a:off x="554584" y="1572768"/>
             <a:ext cx="2084832" cy="914400"/>
           </a:xfrm>
           <a:prstGeom prst="roundRect">
@@ -6360,7 +6400,7 @@
         </p:nvSpPr>
         <p:spPr>
           <a:xfrm>
-            <a:off x="600304" y="1417320"/>
+            <a:off x="600304" y="1572768"/>
             <a:ext cx="1993392" cy="914400"/>
           </a:xfrm>
           <a:prstGeom prst="rect">
@@ -6416,7 +6456,7 @@
         </p:nvSpPr>
         <p:spPr>
           <a:xfrm>
-            <a:off x="2584552" y="1746504"/>
+            <a:off x="2584552" y="1901952"/>
             <a:ext cx="365760" cy="256032"/>
           </a:xfrm>
           <a:prstGeom prst="rightArrow">
@@ -6436,7 +6476,7 @@
         </p:nvSpPr>
         <p:spPr>
           <a:xfrm>
-            <a:off x="2804008" y="1417320"/>
+            <a:off x="2804008" y="1572768"/>
             <a:ext cx="2084832" cy="914400"/>
           </a:xfrm>
           <a:prstGeom prst="roundRect">
@@ -6458,7 +6498,7 @@
         </p:nvSpPr>
         <p:spPr>
           <a:xfrm>
-            <a:off x="2849728" y="1417320"/>
+            <a:off x="2849728" y="1572768"/>
             <a:ext cx="1993392" cy="914400"/>
           </a:xfrm>
           <a:prstGeom prst="rect">
@@ -6514,7 +6554,7 @@
         </p:nvSpPr>
         <p:spPr>
           <a:xfrm>
-            <a:off x="4833976" y="1746504"/>
+            <a:off x="4833976" y="1901952"/>
             <a:ext cx="365760" cy="256032"/>
           </a:xfrm>
           <a:prstGeom prst="rightArrow">
@@ -6534,7 +6574,7 @@
         </p:nvSpPr>
         <p:spPr>
           <a:xfrm>
-            <a:off x="5053432" y="1417320"/>
+            <a:off x="5053432" y="1572768"/>
             <a:ext cx="2084832" cy="914400"/>
           </a:xfrm>
           <a:prstGeom prst="roundRect">
@@ -6556,7 +6596,7 @@
         </p:nvSpPr>
         <p:spPr>
           <a:xfrm>
-            <a:off x="5099152" y="1417320"/>
+            <a:off x="5099152" y="1572768"/>
             <a:ext cx="1993392" cy="914400"/>
           </a:xfrm>
           <a:prstGeom prst="rect">
@@ -6612,7 +6652,7 @@
         </p:nvSpPr>
         <p:spPr>
           <a:xfrm>
-            <a:off x="7083400" y="1746504"/>
+            <a:off x="7083400" y="1901952"/>
             <a:ext cx="365760" cy="256032"/>
           </a:xfrm>
           <a:prstGeom prst="rightArrow">
@@ -6632,7 +6672,7 @@
         </p:nvSpPr>
         <p:spPr>
           <a:xfrm>
-            <a:off x="7302856" y="1417320"/>
+            <a:off x="7302856" y="1572768"/>
             <a:ext cx="2084832" cy="914400"/>
           </a:xfrm>
           <a:prstGeom prst="roundRect">
@@ -6654,7 +6694,7 @@
         </p:nvSpPr>
         <p:spPr>
           <a:xfrm>
-            <a:off x="7348576" y="1417320"/>
+            <a:off x="7348576" y="1572768"/>
             <a:ext cx="1993392" cy="914400"/>
           </a:xfrm>
           <a:prstGeom prst="rect">
@@ -6710,7 +6750,7 @@
         </p:nvSpPr>
         <p:spPr>
           <a:xfrm>
-            <a:off x="9332824" y="1746504"/>
+            <a:off x="9332824" y="1901952"/>
             <a:ext cx="365760" cy="256032"/>
           </a:xfrm>
           <a:prstGeom prst="rightArrow">
@@ -6730,7 +6770,7 @@
         </p:nvSpPr>
         <p:spPr>
           <a:xfrm>
-            <a:off x="9552280" y="1417320"/>
+            <a:off x="9552280" y="1572768"/>
             <a:ext cx="2084832" cy="914400"/>
           </a:xfrm>
           <a:prstGeom prst="roundRect">
@@ -6752,7 +6792,7 @@
         </p:nvSpPr>
         <p:spPr>
           <a:xfrm>
-            <a:off x="9598000" y="1417320"/>
+            <a:off x="9598000" y="1572768"/>
             <a:ext cx="1993392" cy="914400"/>
           </a:xfrm>
           <a:prstGeom prst="rect">
@@ -6808,12 +6848,12 @@
         </p:nvSpPr>
         <p:spPr>
           <a:xfrm>
-            <a:off x="914400" y="2743200"/>
-            <a:ext cx="10362895" cy="2194560"/>
+            <a:off x="914400" y="2697480"/>
+            <a:ext cx="10362895" cy="2606040"/>
           </a:xfrm>
           <a:prstGeom prst="roundRect">
             <a:avLst>
-              <a:gd name="adj" fmla="val 4167"/>
+              <a:gd name="adj" fmla="val 3509"/>
             </a:avLst>
           </a:prstGeom>
           <a:solidFill>
@@ -6830,8 +6870,8 @@
         </p:nvSpPr>
         <p:spPr>
           <a:xfrm>
-            <a:off x="1234440" y="2926080"/>
-            <a:ext cx="9722815" cy="2103120"/>
+            <a:off x="1234440" y="2852928"/>
+            <a:ext cx="9722815" cy="2377440"/>
           </a:xfrm>
           <a:prstGeom prst="rect">
             <a:avLst/>
@@ -6845,12 +6885,12 @@
           <a:p>
             <a:pPr algn="l" indent="0" marL="0">
               <a:spcAft>
-                <a:spcPts val="800"/>
+                <a:spcPts val="600"/>
               </a:spcAft>
               <a:buNone/>
             </a:pPr>
             <a:r>
-              <a:rPr lang="en-US" sz="1300" dirty="0">
+              <a:rPr lang="en-US" sz="1400" dirty="0">
                 <a:solidFill>
                   <a:srgbClr val="8FD8C7"/>
                 </a:solidFill>
@@ -6858,16 +6898,16 @@
                 <a:ea typeface="Courier New" pitchFamily="34" charset="-122"/>
                 <a:cs typeface="Courier New" pitchFamily="34" charset="-120"/>
               </a:rPr>
-              <a:t>Q: What is the top product by revenue and how many invoices does it appear in?</a:t>
-            </a:r>
-            <a:endParaRPr lang="en-US" sz="1300" dirty="0"/>
+              <a:t>Q: Which product has the highest revenue in the catalog?</a:t>
+            </a:r>
+            <a:endParaRPr lang="en-US" sz="1400" dirty="0"/>
           </a:p>
           <a:p>
             <a:pPr algn="l" indent="0" marL="0">
               <a:buNone/>
             </a:pPr>
             <a:r>
-              <a:rPr lang="en-US" sz="1300" dirty="0">
+              <a:rPr lang="en-US" sz="1400" dirty="0">
                 <a:solidFill>
                   <a:srgbClr val="FFFFFF"/>
                 </a:solidFill>
@@ -6875,19 +6915,16 @@
                 <a:ea typeface="Courier New" pitchFamily="34" charset="-122"/>
                 <a:cs typeface="Courier New" pitchFamily="34" charset="-120"/>
               </a:rPr>
-              <a:t>A: [REGENCY CAKESTAND 3 TIER] — ranks 1 of 1,581 products by total revenue;</a:t>
-            </a:r>
-            <a:endParaRPr lang="en-US" sz="1300" dirty="0"/>
+              <a:t>A: [REGENCY CAKESTAND 3 TIER] It ranks 1 out of 1791 products by total revenue.</a:t>
+            </a:r>
+            <a:endParaRPr lang="en-US" sz="1400" dirty="0"/>
           </a:p>
           <a:p>
             <a:pPr algn="l" indent="0" marL="0">
-              <a:spcAft>
-                <a:spcPts val="800"/>
-              </a:spcAft>
-              <a:buNone/>
-            </a:pPr>
-            <a:r>
-              <a:rPr lang="en-US" sz="1300" dirty="0">
+              <a:buNone/>
+            </a:pPr>
+            <a:r>
+              <a:rPr lang="en-US" sz="1400" dirty="0">
                 <a:solidFill>
                   <a:srgbClr val="FFFFFF"/>
                 </a:solidFill>
@@ -6895,63 +6932,114 @@
                 <a:ea typeface="Courier New" pitchFamily="34" charset="-122"/>
                 <a:cs typeface="Courier New" pitchFamily="34" charset="-120"/>
               </a:rPr>
-              <a:t>   the number one best-selling product in the catalog. [Source 1]</a:t>
-            </a:r>
-            <a:endParaRPr lang="en-US" sz="1300" dirty="0"/>
+              <a:t>   It is the top product by revenue: the number one best-selling,</a:t>
+            </a:r>
+            <a:endParaRPr lang="en-US" sz="1400" dirty="0"/>
           </a:p>
           <a:p>
             <a:pPr algn="l" indent="0" marL="0">
               <a:spcAft>
-                <a:spcPts val="800"/>
+                <a:spcPts val="600"/>
               </a:spcAft>
               <a:buNone/>
             </a:pPr>
             <a:r>
-              <a:rPr lang="en-US" sz="1200" dirty="0">
-                <a:solidFill>
-                  <a:srgbClr val="9BC7C0"/>
+              <a:rPr lang="en-US" sz="1400" dirty="0">
+                <a:solidFill>
+                  <a:srgbClr val="FFFFFF"/>
                 </a:solidFill>
                 <a:latin typeface="Courier New" pitchFamily="34" charset="0"/>
                 <a:ea typeface="Courier New" pitchFamily="34" charset="-122"/>
                 <a:cs typeface="Courier New" pitchFamily="34" charset="-120"/>
               </a:rPr>
-              <a:t>Sources: [Source 1] chunk_id=22423_chunk_005  doc_id=22423</a:t>
-            </a:r>
-            <a:endParaRPr lang="en-US" sz="1300" dirty="0"/>
+              <a:t>   highest-revenue product in the entire catalog. [Source 1]</a:t>
+            </a:r>
+            <a:endParaRPr lang="en-US" sz="1400" dirty="0"/>
           </a:p>
           <a:p>
             <a:pPr algn="l" indent="0" marL="0">
               <a:buNone/>
             </a:pPr>
             <a:r>
-              <a:rPr lang="en-US" sz="1200" dirty="0">
-                <a:solidFill>
-                  <a:srgbClr val="8FD8C7"/>
+              <a:rPr lang="en-US" sz="1400" dirty="0">
+                <a:solidFill>
+                  <a:srgbClr val="9BC7C0"/>
                 </a:solidFill>
                 <a:latin typeface="Courier New" pitchFamily="34" charset="0"/>
                 <a:ea typeface="Courier New" pitchFamily="34" charset="-122"/>
                 <a:cs typeface="Courier New" pitchFamily="34" charset="-120"/>
               </a:rPr>
-              <a:t>top-1 per stage:  BM25: 22423 | Vector: 84952C | RRF: 22423 | Rerank: 22423</a:t>
-            </a:r>
-            <a:endParaRPr lang="en-US" sz="1300" dirty="0"/>
+              <a:t>stage-by-stage top-3 ids (each stage re-ranks the candidates):</a:t>
+            </a:r>
+            <a:endParaRPr lang="en-US" sz="1400" dirty="0"/>
           </a:p>
           <a:p>
             <a:pPr algn="l" indent="0" marL="0">
               <a:buNone/>
             </a:pPr>
             <a:r>
-              <a:rPr lang="en-US" sz="1100" i="1" dirty="0">
-                <a:solidFill>
-                  <a:srgbClr val="9BC7C0"/>
+              <a:rPr lang="en-US" sz="1400" b="1" dirty="0">
+                <a:solidFill>
+                  <a:srgbClr val="8FD8C7"/>
                 </a:solidFill>
                 <a:latin typeface="Courier New" pitchFamily="34" charset="0"/>
                 <a:ea typeface="Courier New" pitchFamily="34" charset="-122"/>
                 <a:cs typeface="Courier New" pitchFamily="34" charset="-120"/>
               </a:rPr>
-              <a:t>                  ^ every stage re-ranks — and it shows</a:t>
-            </a:r>
-            <a:endParaRPr lang="en-US" sz="1300" dirty="0"/>
+              <a:t>BM25                  Vector                RRF                   Rerank</a:t>
+            </a:r>
+            <a:endParaRPr lang="en-US" sz="1400" dirty="0"/>
+          </a:p>
+          <a:p>
+            <a:pPr algn="l" indent="0" marL="0">
+              <a:buNone/>
+            </a:pPr>
+            <a:r>
+              <a:rPr lang="en-US" sz="1400" dirty="0">
+                <a:solidFill>
+                  <a:srgbClr val="FFFFFF"/>
+                </a:solidFill>
+                <a:latin typeface="Courier New" pitchFamily="34" charset="0"/>
+                <a:ea typeface="Courier New" pitchFamily="34" charset="-122"/>
+                <a:cs typeface="Courier New" pitchFamily="34" charset="-120"/>
+              </a:rPr>
+              <a:t>22423_chunk_005       22423_chunk_006       22423_chunk_006       22423_chunk_005</a:t>
+            </a:r>
+            <a:endParaRPr lang="en-US" sz="1400" dirty="0"/>
+          </a:p>
+          <a:p>
+            <a:pPr algn="l" indent="0" marL="0">
+              <a:buNone/>
+            </a:pPr>
+            <a:r>
+              <a:rPr lang="en-US" sz="1400" dirty="0">
+                <a:solidFill>
+                  <a:srgbClr val="FFFFFF"/>
+                </a:solidFill>
+                <a:latin typeface="Courier New" pitchFamily="34" charset="0"/>
+                <a:ea typeface="Courier New" pitchFamily="34" charset="-122"/>
+                <a:cs typeface="Courier New" pitchFamily="34" charset="-120"/>
+              </a:rPr>
+              <a:t>22423_chunk_006       22423_chunk_005       22423_chunk_005       22423_chunk_006</a:t>
+            </a:r>
+            <a:endParaRPr lang="en-US" sz="1400" dirty="0"/>
+          </a:p>
+          <a:p>
+            <a:pPr algn="l" indent="0" marL="0">
+              <a:buNone/>
+            </a:pPr>
+            <a:r>
+              <a:rPr lang="en-US" sz="1400" dirty="0">
+                <a:solidFill>
+                  <a:srgbClr val="FFFFFF"/>
+                </a:solidFill>
+                <a:latin typeface="Courier New" pitchFamily="34" charset="0"/>
+                <a:ea typeface="Courier New" pitchFamily="34" charset="-122"/>
+                <a:cs typeface="Courier New" pitchFamily="34" charset="-120"/>
+              </a:rPr>
+              <a:t>21915_chunk_006       84952C_chunk_005      22752_chunk_005       22752_chunk_005</a:t>
+            </a:r>
+            <a:endParaRPr lang="en-US" sz="1400" dirty="0"/>
           </a:p>
         </p:txBody>
       </p:sp>
@@ -7664,12 +7752,12 @@
         </p:nvSpPr>
         <p:spPr>
           <a:xfrm>
-            <a:off x="685800" y="4709160"/>
-            <a:ext cx="10820095" cy="1234440"/>
+            <a:off x="502920" y="4663440"/>
+            <a:ext cx="11183112" cy="1353312"/>
           </a:xfrm>
           <a:prstGeom prst="roundRect">
             <a:avLst>
-              <a:gd name="adj" fmla="val 5926"/>
+              <a:gd name="adj" fmla="val 5405"/>
             </a:avLst>
           </a:prstGeom>
           <a:solidFill>
@@ -7699,8 +7787,8 @@
         </p:blipFill>
         <p:spPr>
           <a:xfrm>
-            <a:off x="868680" y="4864608"/>
-            <a:ext cx="10424160" cy="822960"/>
+            <a:off x="548640" y="4800600"/>
+            <a:ext cx="11091672" cy="874166"/>
           </a:xfrm>
           <a:prstGeom prst="rect">
             <a:avLst/>
@@ -7715,8 +7803,8 @@
         </p:nvSpPr>
         <p:spPr>
           <a:xfrm>
-            <a:off x="868680" y="5989320"/>
-            <a:ext cx="10424160" cy="320040"/>
+            <a:off x="868680" y="6053328"/>
+            <a:ext cx="10424160" cy="301752"/>
           </a:xfrm>
           <a:prstGeom prst="rect">
             <a:avLst/>
@@ -7732,7 +7820,7 @@
               <a:buNone/>
             </a:pPr>
             <a:r>
-              <a:rPr lang="en-US" sz="1200" i="1" dirty="0">
+              <a:rPr lang="en-US" sz="1250" dirty="0">
                 <a:solidFill>
                   <a:srgbClr val="5B7176"/>
                 </a:solidFill>
@@ -7742,7 +7830,7 @@
               </a:rPr>
               <a:t>تشغيلة نظيفة، ‏10‏ من ‏10‏ مهام خضراء في ‏Graph view</a:t>
             </a:r>
-            <a:endParaRPr lang="en-US" sz="1200" dirty="0"/>
+            <a:endParaRPr lang="en-US" sz="1250" dirty="0"/>
           </a:p>
         </p:txBody>
       </p:sp>
@@ -7786,7 +7874,7 @@
         </p:nvSpPr>
         <p:spPr>
           <a:xfrm>
-            <a:off x="11076127" y="384048"/>
+            <a:off x="11076127" y="566928"/>
             <a:ext cx="566928" cy="566928"/>
           </a:xfrm>
           <a:prstGeom prst="ellipse">
@@ -7806,7 +7894,7 @@
         </p:nvSpPr>
         <p:spPr>
           <a:xfrm>
-            <a:off x="11076127" y="384048"/>
+            <a:off x="11076127" y="566928"/>
             <a:ext cx="566928" cy="566928"/>
           </a:xfrm>
           <a:prstGeom prst="rect">
@@ -7845,7 +7933,7 @@
         </p:nvSpPr>
         <p:spPr>
           <a:xfrm>
-            <a:off x="548640" y="347472"/>
+            <a:off x="548640" y="530352"/>
             <a:ext cx="10362895" cy="685800"/>
           </a:xfrm>
           <a:prstGeom prst="rect">
@@ -7884,7 +7972,7 @@
         </p:nvSpPr>
         <p:spPr>
           <a:xfrm>
-            <a:off x="548640" y="429768"/>
+            <a:off x="548640" y="612648"/>
             <a:ext cx="1600200" cy="475488"/>
           </a:xfrm>
           <a:prstGeom prst="roundRect">
@@ -7906,7 +7994,7 @@
         </p:nvSpPr>
         <p:spPr>
           <a:xfrm>
-            <a:off x="548640" y="429768"/>
+            <a:off x="548640" y="612648"/>
             <a:ext cx="1600200" cy="475488"/>
           </a:xfrm>
           <a:prstGeom prst="rect">
@@ -7945,7 +8033,7 @@
         </p:nvSpPr>
         <p:spPr>
           <a:xfrm>
-            <a:off x="6293815" y="1463040"/>
+            <a:off x="6293815" y="1600200"/>
             <a:ext cx="5349240" cy="2103120"/>
           </a:xfrm>
           <a:prstGeom prst="roundRect">
@@ -7972,7 +8060,7 @@
         </p:nvSpPr>
         <p:spPr>
           <a:xfrm>
-            <a:off x="6522415" y="1600200"/>
+            <a:off x="6522415" y="1737360"/>
             <a:ext cx="4892040" cy="457200"/>
           </a:xfrm>
           <a:prstGeom prst="rect">
@@ -8011,7 +8099,7 @@
         </p:nvSpPr>
         <p:spPr>
           <a:xfrm>
-            <a:off x="6568135" y="2148840"/>
+            <a:off x="6568135" y="2286000"/>
             <a:ext cx="4800600" cy="1188720"/>
           </a:xfrm>
           <a:prstGeom prst="rect">
@@ -8072,7 +8160,7 @@
         </p:nvSpPr>
         <p:spPr>
           <a:xfrm>
-            <a:off x="548640" y="1463040"/>
+            <a:off x="548640" y="1600200"/>
             <a:ext cx="5349240" cy="2103120"/>
           </a:xfrm>
           <a:prstGeom prst="roundRect">
@@ -8099,7 +8187,7 @@
         </p:nvSpPr>
         <p:spPr>
           <a:xfrm>
-            <a:off x="777240" y="1600200"/>
+            <a:off x="777240" y="1737360"/>
             <a:ext cx="4892040" cy="457200"/>
           </a:xfrm>
           <a:prstGeom prst="rect">
@@ -8138,7 +8226,7 @@
         </p:nvSpPr>
         <p:spPr>
           <a:xfrm>
-            <a:off x="822960" y="2148840"/>
+            <a:off x="822960" y="2286000"/>
             <a:ext cx="4800600" cy="1188720"/>
           </a:xfrm>
           <a:prstGeom prst="rect">
@@ -8199,12 +8287,12 @@
         </p:nvSpPr>
         <p:spPr>
           <a:xfrm>
-            <a:off x="548640" y="3886200"/>
-            <a:ext cx="11094415" cy="1234440"/>
+            <a:off x="548640" y="4023360"/>
+            <a:ext cx="11094415" cy="1143000"/>
           </a:xfrm>
           <a:prstGeom prst="roundRect">
             <a:avLst>
-              <a:gd name="adj" fmla="val 7407"/>
+              <a:gd name="adj" fmla="val 8000"/>
             </a:avLst>
           </a:prstGeom>
           <a:solidFill>
@@ -8221,8 +8309,8 @@
         </p:nvSpPr>
         <p:spPr>
           <a:xfrm>
-            <a:off x="822960" y="3886200"/>
-            <a:ext cx="10545775" cy="1234440"/>
+            <a:off x="822960" y="4023360"/>
+            <a:ext cx="10545775" cy="1143000"/>
           </a:xfrm>
           <a:prstGeom prst="rect">
             <a:avLst/>
@@ -9101,12 +9189,12 @@
         </p:nvSpPr>
         <p:spPr>
           <a:xfrm>
-            <a:off x="685800" y="3429000"/>
-            <a:ext cx="10820095" cy="1371600"/>
+            <a:off x="502920" y="3383280"/>
+            <a:ext cx="11183112" cy="1417320"/>
           </a:xfrm>
           <a:prstGeom prst="roundRect">
             <a:avLst>
-              <a:gd name="adj" fmla="val 5333"/>
+              <a:gd name="adj" fmla="val 5161"/>
             </a:avLst>
           </a:prstGeom>
           <a:solidFill>
@@ -9131,8 +9219,8 @@
         </p:blipFill>
         <p:spPr>
           <a:xfrm>
-            <a:off x="896112" y="3639312"/>
-            <a:ext cx="10396728" cy="832104"/>
+            <a:off x="548640" y="3520440"/>
+            <a:ext cx="11091672" cy="886968"/>
           </a:xfrm>
           <a:prstGeom prst="rect">
             <a:avLst/>
@@ -9147,7 +9235,7 @@
         </p:nvSpPr>
         <p:spPr>
           <a:xfrm>
-            <a:off x="896112" y="4498848"/>
+            <a:off x="896112" y="4480560"/>
             <a:ext cx="10396728" cy="274320"/>
           </a:xfrm>
           <a:prstGeom prst="rect">
@@ -9164,7 +9252,7 @@
               <a:buNone/>
             </a:pPr>
             <a:r>
-              <a:rPr lang="en-US" sz="1200" b="1" dirty="0">
+              <a:rPr lang="en-US" sz="1250" b="1" dirty="0">
                 <a:solidFill>
                   <a:srgbClr val="E74C3C"/>
                 </a:solidFill>
@@ -9172,13 +9260,13 @@
                 <a:ea typeface="Arial" pitchFamily="34" charset="-122"/>
                 <a:cs typeface="Arial" pitchFamily="34" charset="-120"/>
               </a:rPr>
-              <a:t>أحمر: ‏ge_gate_silver‏ فشلت   ·   </a:t>
+              <a:t>أحمر — ‏ge_gate_silver‏ فشلت   ·   </a:t>
             </a:r>
             <a:pPr rtl="1" algn="ctr" indent="0" marL="0">
               <a:buNone/>
             </a:pPr>
             <a:r>
-              <a:rPr lang="en-US" sz="1200" b="1" dirty="0">
+              <a:rPr lang="en-US" sz="1250" b="1" dirty="0">
                 <a:solidFill>
                   <a:srgbClr val="D68910"/>
                 </a:solidFill>
@@ -9186,9 +9274,9 @@
                 <a:ea typeface="Arial" pitchFamily="34" charset="-122"/>
                 <a:cs typeface="Arial" pitchFamily="34" charset="-120"/>
               </a:rPr>
-              <a:t>أصفر: ثلاث مهام ‏upstream_failed‏ لم تُشغَّل أصلاً</a:t>
-            </a:r>
-            <a:endParaRPr lang="en-US" sz="1200" dirty="0"/>
+              <a:t>أصفر —‏ ثلاث مهام ‏upstream_failed‏ لم تُشغَّل أصلاً</a:t>
+            </a:r>
+            <a:endParaRPr lang="en-US" sz="1250" dirty="0"/>
           </a:p>
         </p:txBody>
       </p:sp>
@@ -9252,7 +9340,7 @@
                 <a:ea typeface="Arial" pitchFamily="34" charset="-122"/>
                 <a:cs typeface="Arial" pitchFamily="34" charset="-120"/>
               </a:rPr>
-              <a:t>وفشل حقيقي غير متعمد: </a:t>
+              <a:t>وفشل حقيقي غير متعمد —‏ </a:t>
             </a:r>
             <a:pPr rtl="1" algn="ctr" indent="0" marL="0">
               <a:buNone/>

</xml_diff>

<commit_message>
Reskin deck with SDAIA visual identity (navy/teal/violet from official brand assets)
Palette extracted from the official SDAIA logo SVG and sdaia.gov.sa inline brand CSS: navy 273470, teal 0E8A8A, mint 33CC99, violet 6258A6. Official logo (clean transparent render, not redrawn) on the title slide. Semantic failure/success colors and all content untouched. Co-Authored-By: Claude Fable 5 <noreply@anthropic.com>
</commit_message>
<xml_diff>
--- a/docs/presentation.pptx
+++ b/docs/presentation.pptx
@@ -512,7 +512,8 @@
           <a:p>
             <a:r>
               <a:rPr lang="en-US" dirty="0"/>
-              <a:t>التحية والتقديم: فريق من أربعة، مشروع ختامي متكامل — استيعاب لحظي، بحيرة بيانات، مساعد RAG، تنسيق Airflow، وجودة تُوقف الأنبوب فعلاً.</a:t>
+              <a:t>التحية والتقديم: فريق من أربعة، مشروع ختامي متكامل — استيعاب لحظي، بحيرة بيانات، مساعد RAG، تنسيق Airflow، وجودة تُوقف الأنبوب فعلاً.
+شعار سدايا الرسمي مستخدم للإسناد attribution: هذا مشروع ختامي لبرنامج تدريبي من أكاديمية سدايا.</a:t>
             </a:r>
             <a:endParaRPr lang="en-US" dirty="0"/>
           </a:p>
@@ -1748,7 +1749,7 @@
     <p:bg>
       <p:bgPr>
         <a:solidFill>
-          <a:srgbClr val="0B3B4C"/>
+          <a:srgbClr val="273470"/>
         </a:solidFill>
       </p:bgPr>
     </p:bg>
@@ -1768,7 +1769,53 @@
       </p:grpSpPr>
       <p:sp>
         <p:nvSpPr>
-          <p:cNvPr id="2" name="Text 0"/>
+          <p:cNvPr id="2" name="Shape 0"/>
+          <p:cNvSpPr/>
+          <p:nvPr/>
+        </p:nvSpPr>
+        <p:spPr>
+          <a:xfrm>
+            <a:off x="411480" y="365760"/>
+            <a:ext cx="2377440" cy="969264"/>
+          </a:xfrm>
+          <a:prstGeom prst="roundRect">
+            <a:avLst>
+              <a:gd name="adj" fmla="val 9434"/>
+            </a:avLst>
+          </a:prstGeom>
+          <a:solidFill>
+            <a:srgbClr val="FFFFFF"/>
+          </a:solidFill>
+          <a:ln/>
+        </p:spPr>
+      </p:sp>
+      <p:pic>
+        <p:nvPicPr>
+          <p:cNvPr id="3" name="Image 0" descr="C:/Users/abdul/AppData/Local/Temp/claude/C--Users-abdul-OneDrive-Islamic-Content-Services-Associations-In-Languages-SDAIA-Modern-Data-Engineering/b95579aa-71c0-4bf0-9522-73ae4aba6a0a/scratchpad/sdaia_logo.png">    </p:cNvPr>
+          <p:cNvPicPr>
+            <a:picLocks noChangeAspect="1"/>
+          </p:cNvPicPr>
+          <p:nvPr/>
+        </p:nvPicPr>
+        <p:blipFill>
+          <a:blip r:embed="rId1"/>
+          <a:stretch>
+            <a:fillRect/>
+          </a:stretch>
+        </p:blipFill>
+        <p:spPr>
+          <a:xfrm>
+            <a:off x="548640" y="484632"/>
+            <a:ext cx="2103120" cy="731520"/>
+          </a:xfrm>
+          <a:prstGeom prst="rect">
+            <a:avLst/>
+          </a:prstGeom>
+        </p:spPr>
+      </p:pic>
+      <p:sp>
+        <p:nvSpPr>
+          <p:cNvPr id="4" name="Text 1"/>
           <p:cNvSpPr/>
           <p:nvPr/>
         </p:nvSpPr>
@@ -1807,7 +1854,7 @@
       </p:sp>
       <p:sp>
         <p:nvSpPr>
-          <p:cNvPr id="3" name="Text 1"/>
+          <p:cNvPr id="5" name="Text 2"/>
           <p:cNvSpPr/>
           <p:nvPr/>
         </p:nvSpPr>
@@ -1832,7 +1879,7 @@
             <a:r>
               <a:rPr lang="en-US" sz="2200" dirty="0">
                 <a:solidFill>
-                  <a:srgbClr val="02C39A"/>
+                  <a:srgbClr val="33CC99"/>
                 </a:solidFill>
                 <a:latin typeface="Arial" pitchFamily="34" charset="0"/>
                 <a:ea typeface="Arial" pitchFamily="34" charset="-122"/>
@@ -1846,7 +1893,7 @@
       </p:sp>
       <p:sp>
         <p:nvSpPr>
-          <p:cNvPr id="4" name="Shape 2"/>
+          <p:cNvPr id="6" name="Shape 3"/>
           <p:cNvSpPr/>
           <p:nvPr/>
         </p:nvSpPr>
@@ -1861,11 +1908,11 @@
             </a:avLst>
           </a:prstGeom>
           <a:solidFill>
-            <a:srgbClr val="10505F"/>
+            <a:srgbClr val="333F82"/>
           </a:solidFill>
           <a:ln w="9525">
             <a:solidFill>
-              <a:srgbClr val="1E6B76"/>
+              <a:srgbClr val="4A55A0"/>
             </a:solidFill>
             <a:prstDash val="solid"/>
           </a:ln>
@@ -1873,7 +1920,7 @@
       </p:sp>
       <p:sp>
         <p:nvSpPr>
-          <p:cNvPr id="5" name="Text 3"/>
+          <p:cNvPr id="7" name="Text 4"/>
           <p:cNvSpPr/>
           <p:nvPr/>
         </p:nvSpPr>
@@ -1912,7 +1959,7 @@
       </p:sp>
       <p:sp>
         <p:nvSpPr>
-          <p:cNvPr id="6" name="Text 4"/>
+          <p:cNvPr id="8" name="Text 5"/>
           <p:cNvSpPr/>
           <p:nvPr/>
         </p:nvSpPr>
@@ -1937,7 +1984,7 @@
             <a:r>
               <a:rPr lang="en-US" sz="1100" dirty="0">
                 <a:solidFill>
-                  <a:srgbClr val="9BC7C0"/>
+                  <a:srgbClr val="B9C0E4"/>
                 </a:solidFill>
                 <a:latin typeface="Arial" pitchFamily="34" charset="0"/>
                 <a:ea typeface="Arial" pitchFamily="34" charset="-122"/>
@@ -1951,7 +1998,7 @@
       </p:sp>
       <p:sp>
         <p:nvSpPr>
-          <p:cNvPr id="7" name="Shape 5"/>
+          <p:cNvPr id="9" name="Shape 6"/>
           <p:cNvSpPr/>
           <p:nvPr/>
         </p:nvSpPr>
@@ -1966,11 +2013,11 @@
             </a:avLst>
           </a:prstGeom>
           <a:solidFill>
-            <a:srgbClr val="10505F"/>
+            <a:srgbClr val="333F82"/>
           </a:solidFill>
           <a:ln w="9525">
             <a:solidFill>
-              <a:srgbClr val="1E6B76"/>
+              <a:srgbClr val="4A55A0"/>
             </a:solidFill>
             <a:prstDash val="solid"/>
           </a:ln>
@@ -1978,7 +2025,7 @@
       </p:sp>
       <p:sp>
         <p:nvSpPr>
-          <p:cNvPr id="8" name="Text 6"/>
+          <p:cNvPr id="10" name="Text 7"/>
           <p:cNvSpPr/>
           <p:nvPr/>
         </p:nvSpPr>
@@ -2017,7 +2064,7 @@
       </p:sp>
       <p:sp>
         <p:nvSpPr>
-          <p:cNvPr id="9" name="Text 7"/>
+          <p:cNvPr id="11" name="Text 8"/>
           <p:cNvSpPr/>
           <p:nvPr/>
         </p:nvSpPr>
@@ -2042,7 +2089,7 @@
             <a:r>
               <a:rPr lang="en-US" sz="1100" dirty="0">
                 <a:solidFill>
-                  <a:srgbClr val="9BC7C0"/>
+                  <a:srgbClr val="B9C0E4"/>
                 </a:solidFill>
                 <a:latin typeface="Arial" pitchFamily="34" charset="0"/>
                 <a:ea typeface="Arial" pitchFamily="34" charset="-122"/>
@@ -2056,7 +2103,7 @@
       </p:sp>
       <p:sp>
         <p:nvSpPr>
-          <p:cNvPr id="10" name="Shape 8"/>
+          <p:cNvPr id="12" name="Shape 9"/>
           <p:cNvSpPr/>
           <p:nvPr/>
         </p:nvSpPr>
@@ -2071,11 +2118,11 @@
             </a:avLst>
           </a:prstGeom>
           <a:solidFill>
-            <a:srgbClr val="10505F"/>
+            <a:srgbClr val="333F82"/>
           </a:solidFill>
           <a:ln w="9525">
             <a:solidFill>
-              <a:srgbClr val="1E6B76"/>
+              <a:srgbClr val="4A55A0"/>
             </a:solidFill>
             <a:prstDash val="solid"/>
           </a:ln>
@@ -2083,7 +2130,7 @@
       </p:sp>
       <p:sp>
         <p:nvSpPr>
-          <p:cNvPr id="11" name="Text 9"/>
+          <p:cNvPr id="13" name="Text 10"/>
           <p:cNvSpPr/>
           <p:nvPr/>
         </p:nvSpPr>
@@ -2122,7 +2169,7 @@
       </p:sp>
       <p:sp>
         <p:nvSpPr>
-          <p:cNvPr id="12" name="Text 10"/>
+          <p:cNvPr id="14" name="Text 11"/>
           <p:cNvSpPr/>
           <p:nvPr/>
         </p:nvSpPr>
@@ -2147,7 +2194,7 @@
             <a:r>
               <a:rPr lang="en-US" sz="1100" dirty="0">
                 <a:solidFill>
-                  <a:srgbClr val="9BC7C0"/>
+                  <a:srgbClr val="B9C0E4"/>
                 </a:solidFill>
                 <a:latin typeface="Arial" pitchFamily="34" charset="0"/>
                 <a:ea typeface="Arial" pitchFamily="34" charset="-122"/>
@@ -2161,7 +2208,7 @@
       </p:sp>
       <p:sp>
         <p:nvSpPr>
-          <p:cNvPr id="13" name="Shape 11"/>
+          <p:cNvPr id="15" name="Shape 12"/>
           <p:cNvSpPr/>
           <p:nvPr/>
         </p:nvSpPr>
@@ -2176,11 +2223,11 @@
             </a:avLst>
           </a:prstGeom>
           <a:solidFill>
-            <a:srgbClr val="10505F"/>
+            <a:srgbClr val="333F82"/>
           </a:solidFill>
           <a:ln w="9525">
             <a:solidFill>
-              <a:srgbClr val="1E6B76"/>
+              <a:srgbClr val="4A55A0"/>
             </a:solidFill>
             <a:prstDash val="solid"/>
           </a:ln>
@@ -2188,7 +2235,7 @@
       </p:sp>
       <p:sp>
         <p:nvSpPr>
-          <p:cNvPr id="14" name="Text 12"/>
+          <p:cNvPr id="16" name="Text 13"/>
           <p:cNvSpPr/>
           <p:nvPr/>
         </p:nvSpPr>
@@ -2227,7 +2274,7 @@
       </p:sp>
       <p:sp>
         <p:nvSpPr>
-          <p:cNvPr id="15" name="Text 13"/>
+          <p:cNvPr id="17" name="Text 14"/>
           <p:cNvSpPr/>
           <p:nvPr/>
         </p:nvSpPr>
@@ -2252,7 +2299,7 @@
             <a:r>
               <a:rPr lang="en-US" sz="1100" dirty="0">
                 <a:solidFill>
-                  <a:srgbClr val="9BC7C0"/>
+                  <a:srgbClr val="B9C0E4"/>
                 </a:solidFill>
                 <a:latin typeface="Arial" pitchFamily="34" charset="0"/>
                 <a:ea typeface="Arial" pitchFamily="34" charset="-122"/>
@@ -2266,7 +2313,7 @@
       </p:sp>
       <p:sp>
         <p:nvSpPr>
-          <p:cNvPr id="16" name="Text 14"/>
+          <p:cNvPr id="18" name="Text 15"/>
           <p:cNvSpPr/>
           <p:nvPr/>
         </p:nvSpPr>
@@ -2305,7 +2352,7 @@
       </p:sp>
       <p:sp>
         <p:nvSpPr>
-          <p:cNvPr id="17" name="Text 15"/>
+          <p:cNvPr id="19" name="Text 16"/>
           <p:cNvSpPr/>
           <p:nvPr/>
         </p:nvSpPr>
@@ -2330,7 +2377,7 @@
             <a:r>
               <a:rPr lang="en-US" sz="1400" dirty="0">
                 <a:solidFill>
-                  <a:srgbClr val="CDE4E0"/>
+                  <a:srgbClr val="CBD2F0"/>
                 </a:solidFill>
                 <a:latin typeface="Arial" pitchFamily="34" charset="0"/>
                 <a:ea typeface="Arial" pitchFamily="34" charset="-122"/>
@@ -2344,7 +2391,7 @@
       </p:sp>
       <p:sp>
         <p:nvSpPr>
-          <p:cNvPr id="18" name="Text 16"/>
+          <p:cNvPr id="20" name="Text 17"/>
           <p:cNvSpPr/>
           <p:nvPr/>
         </p:nvSpPr>
@@ -2369,7 +2416,7 @@
             <a:r>
               <a:rPr lang="en-US" sz="1400" dirty="0">
                 <a:solidFill>
-                  <a:srgbClr val="9BC7C0"/>
+                  <a:srgbClr val="B9C0E4"/>
                 </a:solidFill>
                 <a:latin typeface="Arial" pitchFamily="34" charset="0"/>
                 <a:ea typeface="Arial" pitchFamily="34" charset="-122"/>
@@ -2440,7 +2487,7 @@
             <a:r>
               <a:rPr lang="ar-SA" altLang="en-US" sz="2900" b="1" dirty="0">
                 <a:solidFill>
-                  <a:srgbClr val="0B3B4C"/>
+                  <a:srgbClr val="273470"/>
                 </a:solidFill>
                 <a:latin typeface="Arial" pitchFamily="34" charset="0"/>
                 <a:ea typeface="Arial" pitchFamily="34" charset="-122"/>
@@ -2473,7 +2520,7 @@
           </a:solidFill>
           <a:ln w="12700">
             <a:solidFill>
-              <a:srgbClr val="CFE0DE"/>
+              <a:srgbClr val="D6DAEC"/>
             </a:solidFill>
             <a:prstDash val="solid"/>
           </a:ln>
@@ -2530,7 +2577,7 @@
             <a:r>
               <a:rPr lang="en-US" sz="1150" dirty="0">
                 <a:solidFill>
-                  <a:srgbClr val="5B7176"/>
+                  <a:srgbClr val="5A6285"/>
                 </a:solidFill>
                 <a:latin typeface="Arial" pitchFamily="34" charset="0"/>
                 <a:ea typeface="Arial" pitchFamily="34" charset="-122"/>
@@ -2559,11 +2606,11 @@
             </a:avLst>
           </a:prstGeom>
           <a:solidFill>
-            <a:srgbClr val="F0F6F5"/>
+            <a:srgbClr val="F2F3FA"/>
           </a:solidFill>
           <a:ln w="9525">
             <a:solidFill>
-              <a:srgbClr val="CFE0DE"/>
+              <a:srgbClr val="D6DAEC"/>
             </a:solidFill>
             <a:prstDash val="solid"/>
           </a:ln>
@@ -2596,7 +2643,7 @@
             <a:r>
               <a:rPr lang="en-US" sz="4000" b="1" dirty="0">
                 <a:solidFill>
-                  <a:srgbClr val="0E7C86"/>
+                  <a:srgbClr val="0E8A8A"/>
                 </a:solidFill>
                 <a:latin typeface="Arial" pitchFamily="34" charset="0"/>
                 <a:ea typeface="Arial" pitchFamily="34" charset="-122"/>
@@ -2635,7 +2682,7 @@
             <a:r>
               <a:rPr lang="en-US" sz="1350" dirty="0">
                 <a:solidFill>
-                  <a:srgbClr val="5B7176"/>
+                  <a:srgbClr val="5A6285"/>
                 </a:solidFill>
                 <a:latin typeface="Arial" pitchFamily="34" charset="0"/>
                 <a:ea typeface="Arial" pitchFamily="34" charset="-122"/>
@@ -2664,11 +2711,11 @@
             </a:avLst>
           </a:prstGeom>
           <a:solidFill>
-            <a:srgbClr val="F0F6F5"/>
+            <a:srgbClr val="F2F3FA"/>
           </a:solidFill>
           <a:ln w="9525">
             <a:solidFill>
-              <a:srgbClr val="CFE0DE"/>
+              <a:srgbClr val="D6DAEC"/>
             </a:solidFill>
             <a:prstDash val="solid"/>
           </a:ln>
@@ -2701,7 +2748,7 @@
             <a:r>
               <a:rPr lang="en-US" sz="4000" b="1" dirty="0">
                 <a:solidFill>
-                  <a:srgbClr val="0E7C86"/>
+                  <a:srgbClr val="0E8A8A"/>
                 </a:solidFill>
                 <a:latin typeface="Arial" pitchFamily="34" charset="0"/>
                 <a:ea typeface="Arial" pitchFamily="34" charset="-122"/>
@@ -2740,7 +2787,7 @@
             <a:r>
               <a:rPr lang="en-US" sz="1350" dirty="0">
                 <a:solidFill>
-                  <a:srgbClr val="5B7176"/>
+                  <a:srgbClr val="5A6285"/>
                 </a:solidFill>
                 <a:latin typeface="Arial" pitchFamily="34" charset="0"/>
                 <a:ea typeface="Arial" pitchFamily="34" charset="-122"/>
@@ -2769,11 +2816,11 @@
             </a:avLst>
           </a:prstGeom>
           <a:solidFill>
-            <a:srgbClr val="F0F6F5"/>
+            <a:srgbClr val="F2F3FA"/>
           </a:solidFill>
           <a:ln w="9525">
             <a:solidFill>
-              <a:srgbClr val="CFE0DE"/>
+              <a:srgbClr val="D6DAEC"/>
             </a:solidFill>
             <a:prstDash val="solid"/>
           </a:ln>
@@ -2806,7 +2853,7 @@
             <a:r>
               <a:rPr lang="en-US" sz="4000" b="1" dirty="0">
                 <a:solidFill>
-                  <a:srgbClr val="0E7C86"/>
+                  <a:srgbClr val="0E8A8A"/>
                 </a:solidFill>
                 <a:latin typeface="Arial" pitchFamily="34" charset="0"/>
                 <a:ea typeface="Arial" pitchFamily="34" charset="-122"/>
@@ -2845,7 +2892,7 @@
             <a:r>
               <a:rPr lang="en-US" sz="1350" dirty="0">
                 <a:solidFill>
-                  <a:srgbClr val="5B7176"/>
+                  <a:srgbClr val="5A6285"/>
                 </a:solidFill>
                 <a:latin typeface="Arial" pitchFamily="34" charset="0"/>
                 <a:ea typeface="Arial" pitchFamily="34" charset="-122"/>
@@ -2874,11 +2921,11 @@
             </a:avLst>
           </a:prstGeom>
           <a:solidFill>
-            <a:srgbClr val="F0F6F5"/>
+            <a:srgbClr val="F2F3FA"/>
           </a:solidFill>
           <a:ln w="9525">
             <a:solidFill>
-              <a:srgbClr val="CFE0DE"/>
+              <a:srgbClr val="D6DAEC"/>
             </a:solidFill>
             <a:prstDash val="solid"/>
           </a:ln>
@@ -2911,7 +2958,7 @@
             <a:r>
               <a:rPr lang="en-US" sz="4000" b="1" dirty="0">
                 <a:solidFill>
-                  <a:srgbClr val="02C39A"/>
+                  <a:srgbClr val="33CC99"/>
                 </a:solidFill>
                 <a:latin typeface="Arial" pitchFamily="34" charset="0"/>
                 <a:ea typeface="Arial" pitchFamily="34" charset="-122"/>
@@ -2950,7 +2997,7 @@
             <a:r>
               <a:rPr lang="en-US" sz="1350" dirty="0">
                 <a:solidFill>
-                  <a:srgbClr val="5B7176"/>
+                  <a:srgbClr val="5A6285"/>
                 </a:solidFill>
                 <a:latin typeface="Arial" pitchFamily="34" charset="0"/>
                 <a:ea typeface="Arial" pitchFamily="34" charset="-122"/>
@@ -2976,7 +3023,7 @@
     <p:bg>
       <p:bgPr>
         <a:solidFill>
-          <a:srgbClr val="0B3B4C"/>
+          <a:srgbClr val="273470"/>
         </a:solidFill>
       </p:bgPr>
     </p:bg>
@@ -3060,7 +3107,7 @@
             <a:r>
               <a:rPr lang="en-US" sz="1800" dirty="0">
                 <a:solidFill>
-                  <a:srgbClr val="9BC7C0"/>
+                  <a:srgbClr val="B9C0E4"/>
                 </a:solidFill>
                 <a:latin typeface="Arial" pitchFamily="34" charset="0"/>
                 <a:ea typeface="Arial" pitchFamily="34" charset="-122"/>
@@ -3089,11 +3136,11 @@
             </a:avLst>
           </a:prstGeom>
           <a:solidFill>
-            <a:srgbClr val="10505F"/>
+            <a:srgbClr val="333F82"/>
           </a:solidFill>
           <a:ln w="15875">
             <a:solidFill>
-              <a:srgbClr val="02C39A"/>
+              <a:srgbClr val="33CC99"/>
             </a:solidFill>
             <a:prstDash val="solid"/>
           </a:ln>
@@ -3126,7 +3173,7 @@
             <a:r>
               <a:rPr lang="en-US" sz="1900" b="1" dirty="0">
                 <a:solidFill>
-                  <a:srgbClr val="02C39A"/>
+                  <a:srgbClr val="33CC99"/>
                 </a:solidFill>
                 <a:latin typeface="Courier New" pitchFamily="34" charset="0"/>
                 <a:ea typeface="Courier New" pitchFamily="34" charset="-122"/>
@@ -3204,7 +3251,7 @@
             <a:r>
               <a:rPr lang="en-US" sz="1200" dirty="0">
                 <a:solidFill>
-                  <a:srgbClr val="9BC7C0"/>
+                  <a:srgbClr val="B9C0E4"/>
                 </a:solidFill>
                 <a:latin typeface="Arial" pitchFamily="34" charset="0"/>
                 <a:ea typeface="Arial" pitchFamily="34" charset="-122"/>
@@ -3275,7 +3322,7 @@
             <a:r>
               <a:rPr lang="ar-SA" altLang="en-US" sz="2900" b="1" dirty="0">
                 <a:solidFill>
-                  <a:srgbClr val="0B3B4C"/>
+                  <a:srgbClr val="273470"/>
                 </a:solidFill>
                 <a:latin typeface="Arial" pitchFamily="34" charset="0"/>
                 <a:ea typeface="Arial" pitchFamily="34" charset="-122"/>
@@ -3304,11 +3351,11 @@
             </a:avLst>
           </a:prstGeom>
           <a:solidFill>
-            <a:srgbClr val="F0F6F5"/>
+            <a:srgbClr val="F2F3FA"/>
           </a:solidFill>
           <a:ln w="9525">
             <a:solidFill>
-              <a:srgbClr val="CFE0DE"/>
+              <a:srgbClr val="D6DAEC"/>
             </a:solidFill>
             <a:prstDash val="solid"/>
           </a:ln>
@@ -3341,7 +3388,7 @@
             <a:r>
               <a:rPr lang="en-US" sz="4000" b="1" dirty="0">
                 <a:solidFill>
-                  <a:srgbClr val="0E7C86"/>
+                  <a:srgbClr val="0E8A8A"/>
                 </a:solidFill>
                 <a:latin typeface="Arial" pitchFamily="34" charset="0"/>
                 <a:ea typeface="Arial" pitchFamily="34" charset="-122"/>
@@ -3380,7 +3427,7 @@
             <a:r>
               <a:rPr lang="en-US" sz="1350" dirty="0">
                 <a:solidFill>
-                  <a:srgbClr val="5B7176"/>
+                  <a:srgbClr val="5A6285"/>
                 </a:solidFill>
                 <a:latin typeface="Arial" pitchFamily="34" charset="0"/>
                 <a:ea typeface="Arial" pitchFamily="34" charset="-122"/>
@@ -3409,11 +3456,11 @@
             </a:avLst>
           </a:prstGeom>
           <a:solidFill>
-            <a:srgbClr val="F0F6F5"/>
+            <a:srgbClr val="F2F3FA"/>
           </a:solidFill>
           <a:ln w="9525">
             <a:solidFill>
-              <a:srgbClr val="CFE0DE"/>
+              <a:srgbClr val="D6DAEC"/>
             </a:solidFill>
             <a:prstDash val="solid"/>
           </a:ln>
@@ -3485,7 +3532,7 @@
             <a:r>
               <a:rPr lang="en-US" sz="1350" dirty="0">
                 <a:solidFill>
-                  <a:srgbClr val="5B7176"/>
+                  <a:srgbClr val="5A6285"/>
                 </a:solidFill>
                 <a:latin typeface="Arial" pitchFamily="34" charset="0"/>
                 <a:ea typeface="Arial" pitchFamily="34" charset="-122"/>
@@ -3514,11 +3561,11 @@
             </a:avLst>
           </a:prstGeom>
           <a:solidFill>
-            <a:srgbClr val="F0F6F5"/>
+            <a:srgbClr val="F2F3FA"/>
           </a:solidFill>
           <a:ln w="9525">
             <a:solidFill>
-              <a:srgbClr val="CFE0DE"/>
+              <a:srgbClr val="D6DAEC"/>
             </a:solidFill>
             <a:prstDash val="solid"/>
           </a:ln>
@@ -3590,7 +3637,7 @@
             <a:r>
               <a:rPr lang="en-US" sz="1350" dirty="0">
                 <a:solidFill>
-                  <a:srgbClr val="5B7176"/>
+                  <a:srgbClr val="5A6285"/>
                 </a:solidFill>
                 <a:latin typeface="Arial" pitchFamily="34" charset="0"/>
                 <a:ea typeface="Arial" pitchFamily="34" charset="-122"/>
@@ -3619,11 +3666,11 @@
             </a:avLst>
           </a:prstGeom>
           <a:solidFill>
-            <a:srgbClr val="F0F6F5"/>
+            <a:srgbClr val="F2F3FA"/>
           </a:solidFill>
           <a:ln w="9525">
             <a:solidFill>
-              <a:srgbClr val="CFE0DE"/>
+              <a:srgbClr val="D6DAEC"/>
             </a:solidFill>
             <a:prstDash val="solid"/>
           </a:ln>
@@ -3695,7 +3742,7 @@
             <a:r>
               <a:rPr lang="en-US" sz="1350" dirty="0">
                 <a:solidFill>
-                  <a:srgbClr val="5B7176"/>
+                  <a:srgbClr val="5A6285"/>
                 </a:solidFill>
                 <a:latin typeface="Arial" pitchFamily="34" charset="0"/>
                 <a:ea typeface="Arial" pitchFamily="34" charset="-122"/>
@@ -3722,7 +3769,7 @@
             <a:avLst/>
           </a:prstGeom>
           <a:solidFill>
-            <a:srgbClr val="02C39A"/>
+            <a:srgbClr val="33CC99"/>
           </a:solidFill>
           <a:ln/>
         </p:spPr>
@@ -3744,7 +3791,7 @@
             </a:avLst>
           </a:prstGeom>
           <a:solidFill>
-            <a:srgbClr val="0B3B4C"/>
+            <a:srgbClr val="273470"/>
           </a:solidFill>
           <a:ln/>
         </p:spPr>
@@ -3847,7 +3894,7 @@
             <a:r>
               <a:rPr lang="ar-SA" altLang="en-US" sz="2900" b="1" dirty="0">
                 <a:solidFill>
-                  <a:srgbClr val="0B3B4C"/>
+                  <a:srgbClr val="273470"/>
                 </a:solidFill>
                 <a:latin typeface="Arial" pitchFamily="34" charset="0"/>
                 <a:ea typeface="Arial" pitchFamily="34" charset="-122"/>
@@ -3876,7 +3923,7 @@
             </a:avLst>
           </a:prstGeom>
           <a:solidFill>
-            <a:srgbClr val="0E7C86"/>
+            <a:srgbClr val="0E8A8A"/>
           </a:solidFill>
           <a:ln/>
         </p:spPr>
@@ -3954,7 +4001,7 @@
             </a:avLst>
           </a:prstGeom>
           <a:solidFill>
-            <a:srgbClr val="0B3B4C"/>
+            <a:srgbClr val="273470"/>
           </a:solidFill>
           <a:ln/>
         </p:spPr>
@@ -4032,7 +4079,7 @@
             </a:avLst>
           </a:prstGeom>
           <a:solidFill>
-            <a:srgbClr val="0E7C86"/>
+            <a:srgbClr val="0E8A8A"/>
           </a:solidFill>
           <a:ln/>
         </p:spPr>
@@ -4110,7 +4157,7 @@
             </a:avLst>
           </a:prstGeom>
           <a:solidFill>
-            <a:srgbClr val="02C39A"/>
+            <a:srgbClr val="33CC99"/>
           </a:solidFill>
           <a:ln/>
         </p:spPr>
@@ -4142,7 +4189,7 @@
             <a:r>
               <a:rPr lang="en-US" sz="1300" b="1" dirty="0">
                 <a:solidFill>
-                  <a:srgbClr val="0B3B4C"/>
+                  <a:srgbClr val="273470"/>
                 </a:solidFill>
                 <a:latin typeface="Arial" pitchFamily="34" charset="0"/>
                 <a:ea typeface="Arial" pitchFamily="34" charset="-122"/>
@@ -4159,7 +4206,7 @@
             <a:r>
               <a:rPr lang="en-US" sz="1000" dirty="0">
                 <a:solidFill>
-                  <a:srgbClr val="0B3B4C"/>
+                  <a:srgbClr val="273470"/>
                 </a:solidFill>
                 <a:latin typeface="Arial" pitchFamily="34" charset="0"/>
                 <a:ea typeface="Arial" pitchFamily="34" charset="-122"/>
@@ -4188,7 +4235,7 @@
             </a:avLst>
           </a:prstGeom>
           <a:solidFill>
-            <a:srgbClr val="0E7C86"/>
+            <a:srgbClr val="0E8A8A"/>
           </a:solidFill>
           <a:ln/>
         </p:spPr>
@@ -4264,7 +4311,7 @@
             <a:avLst/>
           </a:prstGeom>
           <a:solidFill>
-            <a:srgbClr val="5B7176"/>
+            <a:srgbClr val="5A6285"/>
           </a:solidFill>
           <a:ln/>
         </p:spPr>
@@ -4284,7 +4331,7 @@
             <a:avLst/>
           </a:prstGeom>
           <a:solidFill>
-            <a:srgbClr val="5B7176"/>
+            <a:srgbClr val="5A6285"/>
           </a:solidFill>
           <a:ln/>
         </p:spPr>
@@ -4304,7 +4351,7 @@
             <a:avLst/>
           </a:prstGeom>
           <a:solidFill>
-            <a:srgbClr val="5B7176"/>
+            <a:srgbClr val="5A6285"/>
           </a:solidFill>
           <a:ln/>
         </p:spPr>
@@ -4324,7 +4371,7 @@
             <a:avLst/>
           </a:prstGeom>
           <a:solidFill>
-            <a:srgbClr val="5B7176"/>
+            <a:srgbClr val="5A6285"/>
           </a:solidFill>
           <a:ln/>
         </p:spPr>
@@ -4442,7 +4489,7 @@
             <a:avLst/>
           </a:prstGeom>
           <a:solidFill>
-            <a:srgbClr val="5B7176"/>
+            <a:srgbClr val="5A6285"/>
           </a:solidFill>
           <a:ln/>
         </p:spPr>
@@ -4464,7 +4511,7 @@
             </a:avLst>
           </a:prstGeom>
           <a:solidFill>
-            <a:srgbClr val="02C39A"/>
+            <a:srgbClr val="33CC99"/>
           </a:solidFill>
           <a:ln/>
         </p:spPr>
@@ -4496,7 +4543,7 @@
             <a:r>
               <a:rPr lang="en-US" sz="1300" b="1" dirty="0">
                 <a:solidFill>
-                  <a:srgbClr val="0B3B4C"/>
+                  <a:srgbClr val="273470"/>
                 </a:solidFill>
                 <a:latin typeface="Arial" pitchFamily="34" charset="0"/>
                 <a:ea typeface="Arial" pitchFamily="34" charset="-122"/>
@@ -4513,7 +4560,7 @@
             <a:r>
               <a:rPr lang="en-US" sz="1000" dirty="0">
                 <a:solidFill>
-                  <a:srgbClr val="0B3B4C"/>
+                  <a:srgbClr val="273470"/>
                 </a:solidFill>
                 <a:latin typeface="Arial" pitchFamily="34" charset="0"/>
                 <a:ea typeface="Arial" pitchFamily="34" charset="-122"/>
@@ -4542,7 +4589,7 @@
             </a:avLst>
           </a:prstGeom>
           <a:solidFill>
-            <a:srgbClr val="0E7C86"/>
+            <a:srgbClr val="0E8A8A"/>
           </a:solidFill>
           <a:ln/>
         </p:spPr>
@@ -4620,7 +4667,7 @@
             </a:avLst>
           </a:prstGeom>
           <a:solidFill>
-            <a:srgbClr val="0B3B4C"/>
+            <a:srgbClr val="273470"/>
           </a:solidFill>
           <a:ln/>
         </p:spPr>
@@ -4698,7 +4745,7 @@
             </a:avLst>
           </a:prstGeom>
           <a:solidFill>
-            <a:srgbClr val="02C39A"/>
+            <a:srgbClr val="33CC99"/>
           </a:solidFill>
           <a:ln/>
         </p:spPr>
@@ -4730,7 +4777,7 @@
             <a:r>
               <a:rPr lang="en-US" sz="1300" b="1" dirty="0">
                 <a:solidFill>
-                  <a:srgbClr val="0B3B4C"/>
+                  <a:srgbClr val="273470"/>
                 </a:solidFill>
                 <a:latin typeface="Arial" pitchFamily="34" charset="0"/>
                 <a:ea typeface="Arial" pitchFamily="34" charset="-122"/>
@@ -4747,7 +4794,7 @@
             <a:r>
               <a:rPr lang="en-US" sz="1000" dirty="0">
                 <a:solidFill>
-                  <a:srgbClr val="0B3B4C"/>
+                  <a:srgbClr val="273470"/>
                 </a:solidFill>
                 <a:latin typeface="Arial" pitchFamily="34" charset="0"/>
                 <a:ea typeface="Arial" pitchFamily="34" charset="-122"/>
@@ -4774,7 +4821,7 @@
             <a:avLst/>
           </a:prstGeom>
           <a:solidFill>
-            <a:srgbClr val="5B7176"/>
+            <a:srgbClr val="5A6285"/>
           </a:solidFill>
           <a:ln/>
         </p:spPr>
@@ -4794,7 +4841,7 @@
             <a:avLst/>
           </a:prstGeom>
           <a:solidFill>
-            <a:srgbClr val="5B7176"/>
+            <a:srgbClr val="5A6285"/>
           </a:solidFill>
           <a:ln/>
         </p:spPr>
@@ -4814,7 +4861,7 @@
             <a:avLst/>
           </a:prstGeom>
           <a:solidFill>
-            <a:srgbClr val="5B7176"/>
+            <a:srgbClr val="5A6285"/>
           </a:solidFill>
           <a:ln/>
         </p:spPr>
@@ -4836,11 +4883,11 @@
             </a:avLst>
           </a:prstGeom>
           <a:solidFill>
-            <a:srgbClr val="F0F6F5"/>
+            <a:srgbClr val="F2F3FA"/>
           </a:solidFill>
           <a:ln w="9525">
             <a:solidFill>
-              <a:srgbClr val="CFE0DE"/>
+              <a:srgbClr val="D6DAEC"/>
             </a:solidFill>
             <a:prstDash val="solid"/>
           </a:ln>
@@ -4873,7 +4920,7 @@
             <a:r>
               <a:rPr lang="en-US" sz="1600" b="1" dirty="0">
                 <a:solidFill>
-                  <a:srgbClr val="0E7C86"/>
+                  <a:srgbClr val="0E8A8A"/>
                 </a:solidFill>
                 <a:latin typeface="Arial" pitchFamily="34" charset="0"/>
                 <a:ea typeface="Arial" pitchFamily="34" charset="-122"/>
@@ -4887,7 +4934,7 @@
             <a:r>
               <a:rPr lang="en-US" sz="1600" dirty="0">
                 <a:solidFill>
-                  <a:srgbClr val="16333C"/>
+                  <a:srgbClr val="1C2547"/>
                 </a:solidFill>
                 <a:latin typeface="Arial" pitchFamily="34" charset="0"/>
                 <a:ea typeface="Arial" pitchFamily="34" charset="-122"/>
@@ -4901,7 +4948,7 @@
             <a:r>
               <a:rPr lang="en-US" sz="1600" b="1" dirty="0">
                 <a:solidFill>
-                  <a:srgbClr val="0E7C86"/>
+                  <a:srgbClr val="0E8A8A"/>
                 </a:solidFill>
                 <a:latin typeface="Arial" pitchFamily="34" charset="0"/>
                 <a:ea typeface="Arial" pitchFamily="34" charset="-122"/>
@@ -4915,7 +4962,7 @@
             <a:r>
               <a:rPr lang="en-US" sz="1600" dirty="0">
                 <a:solidFill>
-                  <a:srgbClr val="16333C"/>
+                  <a:srgbClr val="1C2547"/>
                 </a:solidFill>
                 <a:latin typeface="Arial" pitchFamily="34" charset="0"/>
                 <a:ea typeface="Arial" pitchFamily="34" charset="-122"/>
@@ -4974,7 +5021,7 @@
             <a:avLst/>
           </a:prstGeom>
           <a:solidFill>
-            <a:srgbClr val="0E7C86"/>
+            <a:srgbClr val="6258A6"/>
           </a:solidFill>
           <a:ln/>
         </p:spPr>
@@ -5045,7 +5092,7 @@
             <a:r>
               <a:rPr lang="ar-SA" altLang="en-US" sz="2900" b="1" dirty="0">
                 <a:solidFill>
-                  <a:srgbClr val="0B3B4C"/>
+                  <a:srgbClr val="273470"/>
                 </a:solidFill>
                 <a:latin typeface="Arial" pitchFamily="34" charset="0"/>
                 <a:ea typeface="Arial" pitchFamily="34" charset="-122"/>
@@ -5074,7 +5121,7 @@
             </a:avLst>
           </a:prstGeom>
           <a:solidFill>
-            <a:srgbClr val="02C39A"/>
+            <a:srgbClr val="33CC99"/>
           </a:solidFill>
           <a:ln/>
         </p:spPr>
@@ -5106,7 +5153,7 @@
             <a:r>
               <a:rPr lang="en-US" sz="1500" b="1" dirty="0">
                 <a:solidFill>
-                  <a:srgbClr val="0B3B4C"/>
+                  <a:srgbClr val="273470"/>
                 </a:solidFill>
                 <a:latin typeface="Arial" pitchFamily="34" charset="0"/>
                 <a:ea typeface="Arial" pitchFamily="34" charset="-122"/>
@@ -5149,7 +5196,7 @@
             <a:r>
               <a:rPr lang="en-US" sz="1700" dirty="0">
                 <a:solidFill>
-                  <a:srgbClr val="16333C"/>
+                  <a:srgbClr val="1C2547"/>
                 </a:solidFill>
                 <a:latin typeface="Arial" pitchFamily="34" charset="0"/>
                 <a:ea typeface="Arial" pitchFamily="34" charset="-122"/>
@@ -5170,7 +5217,7 @@
             <a:r>
               <a:rPr lang="en-US" sz="1700" dirty="0">
                 <a:solidFill>
-                  <a:srgbClr val="16333C"/>
+                  <a:srgbClr val="1C2547"/>
                 </a:solidFill>
                 <a:latin typeface="Arial" pitchFamily="34" charset="0"/>
                 <a:ea typeface="Arial" pitchFamily="34" charset="-122"/>
@@ -5191,7 +5238,7 @@
             <a:r>
               <a:rPr lang="en-US" sz="1700" dirty="0">
                 <a:solidFill>
-                  <a:srgbClr val="16333C"/>
+                  <a:srgbClr val="1C2547"/>
                 </a:solidFill>
                 <a:latin typeface="Arial" pitchFamily="34" charset="0"/>
                 <a:ea typeface="Arial" pitchFamily="34" charset="-122"/>
@@ -5212,7 +5259,7 @@
             <a:r>
               <a:rPr lang="en-US" sz="1700" dirty="0">
                 <a:solidFill>
-                  <a:srgbClr val="16333C"/>
+                  <a:srgbClr val="1C2547"/>
                 </a:solidFill>
                 <a:latin typeface="Arial" pitchFamily="34" charset="0"/>
                 <a:ea typeface="Arial" pitchFamily="34" charset="-122"/>
@@ -5241,11 +5288,11 @@
             </a:avLst>
           </a:prstGeom>
           <a:solidFill>
-            <a:srgbClr val="F0F6F5"/>
+            <a:srgbClr val="F2F3FA"/>
           </a:solidFill>
           <a:ln w="9525">
             <a:solidFill>
-              <a:srgbClr val="CFE0DE"/>
+              <a:srgbClr val="D6DAEC"/>
             </a:solidFill>
             <a:prstDash val="solid"/>
           </a:ln>
@@ -5278,7 +5325,7 @@
             <a:r>
               <a:rPr lang="en-US" sz="4000" b="1" dirty="0">
                 <a:solidFill>
-                  <a:srgbClr val="0E7C86"/>
+                  <a:srgbClr val="0E8A8A"/>
                 </a:solidFill>
                 <a:latin typeface="Arial" pitchFamily="34" charset="0"/>
                 <a:ea typeface="Arial" pitchFamily="34" charset="-122"/>
@@ -5317,7 +5364,7 @@
             <a:r>
               <a:rPr lang="en-US" sz="1350" dirty="0">
                 <a:solidFill>
-                  <a:srgbClr val="5B7176"/>
+                  <a:srgbClr val="5A6285"/>
                 </a:solidFill>
                 <a:latin typeface="Arial" pitchFamily="34" charset="0"/>
                 <a:ea typeface="Arial" pitchFamily="34" charset="-122"/>
@@ -5346,11 +5393,11 @@
             </a:avLst>
           </a:prstGeom>
           <a:solidFill>
-            <a:srgbClr val="F0F6F5"/>
+            <a:srgbClr val="F2F3FA"/>
           </a:solidFill>
           <a:ln w="9525">
             <a:solidFill>
-              <a:srgbClr val="CFE0DE"/>
+              <a:srgbClr val="D6DAEC"/>
             </a:solidFill>
             <a:prstDash val="solid"/>
           </a:ln>
@@ -5422,7 +5469,7 @@
             <a:r>
               <a:rPr lang="en-US" sz="1350" dirty="0">
                 <a:solidFill>
-                  <a:srgbClr val="5B7176"/>
+                  <a:srgbClr val="5A6285"/>
                 </a:solidFill>
                 <a:latin typeface="Arial" pitchFamily="34" charset="0"/>
                 <a:ea typeface="Arial" pitchFamily="34" charset="-122"/>
@@ -5461,7 +5508,7 @@
             <a:r>
               <a:rPr lang="en-US" sz="1400" dirty="0">
                 <a:solidFill>
-                  <a:srgbClr val="5B7176"/>
+                  <a:srgbClr val="5A6285"/>
                 </a:solidFill>
                 <a:latin typeface="Arial" pitchFamily="34" charset="0"/>
                 <a:ea typeface="Arial" pitchFamily="34" charset="-122"/>
@@ -5490,11 +5537,11 @@
             </a:avLst>
           </a:prstGeom>
           <a:solidFill>
-            <a:srgbClr val="E2F3EE"/>
+            <a:srgbClr val="E6F7F1"/>
           </a:solidFill>
           <a:ln w="12700">
             <a:solidFill>
-              <a:srgbClr val="02C39A"/>
+              <a:srgbClr val="33CC99"/>
             </a:solidFill>
             <a:prstDash val="solid"/>
           </a:ln>
@@ -5527,7 +5574,7 @@
             <a:r>
               <a:rPr lang="en-US" sz="1600" b="1" dirty="0">
                 <a:solidFill>
-                  <a:srgbClr val="0E7C86"/>
+                  <a:srgbClr val="0E8A8A"/>
                 </a:solidFill>
                 <a:latin typeface="Arial" pitchFamily="34" charset="0"/>
                 <a:ea typeface="Arial" pitchFamily="34" charset="-122"/>
@@ -5541,7 +5588,7 @@
             <a:r>
               <a:rPr lang="en-US" sz="1600" dirty="0">
                 <a:solidFill>
-                  <a:srgbClr val="16333C"/>
+                  <a:srgbClr val="1C2547"/>
                 </a:solidFill>
                 <a:latin typeface="Arial" pitchFamily="34" charset="0"/>
                 <a:ea typeface="Arial" pitchFamily="34" charset="-122"/>
@@ -5600,7 +5647,7 @@
             <a:avLst/>
           </a:prstGeom>
           <a:solidFill>
-            <a:srgbClr val="0E7C86"/>
+            <a:srgbClr val="6258A6"/>
           </a:solidFill>
           <a:ln/>
         </p:spPr>
@@ -5671,7 +5718,7 @@
             <a:r>
               <a:rPr lang="ar-SA" altLang="en-US" sz="2900" b="1" dirty="0">
                 <a:solidFill>
-                  <a:srgbClr val="0B3B4C"/>
+                  <a:srgbClr val="273470"/>
                 </a:solidFill>
                 <a:latin typeface="Arial" pitchFamily="34" charset="0"/>
                 <a:ea typeface="Arial" pitchFamily="34" charset="-122"/>
@@ -5700,7 +5747,7 @@
             </a:avLst>
           </a:prstGeom>
           <a:solidFill>
-            <a:srgbClr val="02C39A"/>
+            <a:srgbClr val="33CC99"/>
           </a:solidFill>
           <a:ln/>
         </p:spPr>
@@ -5732,7 +5779,7 @@
             <a:r>
               <a:rPr lang="en-US" sz="1500" b="1" dirty="0">
                 <a:solidFill>
-                  <a:srgbClr val="0B3B4C"/>
+                  <a:srgbClr val="273470"/>
                 </a:solidFill>
                 <a:latin typeface="Arial" pitchFamily="34" charset="0"/>
                 <a:ea typeface="Arial" pitchFamily="34" charset="-122"/>
@@ -5775,7 +5822,7 @@
             <a:r>
               <a:rPr lang="en-US" sz="1700" dirty="0">
                 <a:solidFill>
-                  <a:srgbClr val="16333C"/>
+                  <a:srgbClr val="1C2547"/>
                 </a:solidFill>
                 <a:latin typeface="Arial" pitchFamily="34" charset="0"/>
                 <a:ea typeface="Arial" pitchFamily="34" charset="-122"/>
@@ -5796,7 +5843,7 @@
             <a:r>
               <a:rPr lang="en-US" sz="1700" dirty="0">
                 <a:solidFill>
-                  <a:srgbClr val="16333C"/>
+                  <a:srgbClr val="1C2547"/>
                 </a:solidFill>
                 <a:latin typeface="Arial" pitchFamily="34" charset="0"/>
                 <a:ea typeface="Arial" pitchFamily="34" charset="-122"/>
@@ -5817,7 +5864,7 @@
             <a:r>
               <a:rPr lang="en-US" sz="1700" dirty="0">
                 <a:solidFill>
-                  <a:srgbClr val="16333C"/>
+                  <a:srgbClr val="1C2547"/>
                 </a:solidFill>
                 <a:latin typeface="Arial" pitchFamily="34" charset="0"/>
                 <a:ea typeface="Arial" pitchFamily="34" charset="-122"/>
@@ -5838,7 +5885,7 @@
             <a:r>
               <a:rPr lang="en-US" sz="1700" dirty="0">
                 <a:solidFill>
-                  <a:srgbClr val="16333C"/>
+                  <a:srgbClr val="1C2547"/>
                 </a:solidFill>
                 <a:latin typeface="Arial" pitchFamily="34" charset="0"/>
                 <a:ea typeface="Arial" pitchFamily="34" charset="-122"/>
@@ -5867,11 +5914,11 @@
             </a:avLst>
           </a:prstGeom>
           <a:solidFill>
-            <a:srgbClr val="F0F6F5"/>
+            <a:srgbClr val="F2F3FA"/>
           </a:solidFill>
           <a:ln w="9525">
             <a:solidFill>
-              <a:srgbClr val="CFE0DE"/>
+              <a:srgbClr val="D6DAEC"/>
             </a:solidFill>
             <a:prstDash val="solid"/>
           </a:ln>
@@ -5904,7 +5951,7 @@
             <a:r>
               <a:rPr lang="en-US" sz="4000" b="1" dirty="0">
                 <a:solidFill>
-                  <a:srgbClr val="0E7C86"/>
+                  <a:srgbClr val="0E8A8A"/>
                 </a:solidFill>
                 <a:latin typeface="Arial" pitchFamily="34" charset="0"/>
                 <a:ea typeface="Arial" pitchFamily="34" charset="-122"/>
@@ -5943,7 +5990,7 @@
             <a:r>
               <a:rPr lang="en-US" sz="1350" dirty="0">
                 <a:solidFill>
-                  <a:srgbClr val="5B7176"/>
+                  <a:srgbClr val="5A6285"/>
                 </a:solidFill>
                 <a:latin typeface="Arial" pitchFamily="34" charset="0"/>
                 <a:ea typeface="Arial" pitchFamily="34" charset="-122"/>
@@ -5972,11 +6019,11 @@
             </a:avLst>
           </a:prstGeom>
           <a:solidFill>
-            <a:srgbClr val="F0F6F5"/>
+            <a:srgbClr val="F2F3FA"/>
           </a:solidFill>
           <a:ln w="9525">
             <a:solidFill>
-              <a:srgbClr val="CFE0DE"/>
+              <a:srgbClr val="D6DAEC"/>
             </a:solidFill>
             <a:prstDash val="solid"/>
           </a:ln>
@@ -6009,7 +6056,7 @@
             <a:r>
               <a:rPr lang="en-US" sz="4000" b="1" dirty="0">
                 <a:solidFill>
-                  <a:srgbClr val="02C39A"/>
+                  <a:srgbClr val="33CC99"/>
                 </a:solidFill>
                 <a:latin typeface="Arial" pitchFamily="34" charset="0"/>
                 <a:ea typeface="Arial" pitchFamily="34" charset="-122"/>
@@ -6048,7 +6095,7 @@
             <a:r>
               <a:rPr lang="en-US" sz="1350" dirty="0">
                 <a:solidFill>
-                  <a:srgbClr val="5B7176"/>
+                  <a:srgbClr val="5A6285"/>
                 </a:solidFill>
                 <a:latin typeface="Arial" pitchFamily="34" charset="0"/>
                 <a:ea typeface="Arial" pitchFamily="34" charset="-122"/>
@@ -6087,7 +6134,7 @@
             <a:r>
               <a:rPr lang="en-US" sz="1400" dirty="0">
                 <a:solidFill>
-                  <a:srgbClr val="5B7176"/>
+                  <a:srgbClr val="5A6285"/>
                 </a:solidFill>
                 <a:latin typeface="Arial" pitchFamily="34" charset="0"/>
                 <a:ea typeface="Arial" pitchFamily="34" charset="-122"/>
@@ -6116,11 +6163,11 @@
             </a:avLst>
           </a:prstGeom>
           <a:solidFill>
-            <a:srgbClr val="E2F3EE"/>
+            <a:srgbClr val="E6F7F1"/>
           </a:solidFill>
           <a:ln w="12700">
             <a:solidFill>
-              <a:srgbClr val="02C39A"/>
+              <a:srgbClr val="33CC99"/>
             </a:solidFill>
             <a:prstDash val="solid"/>
           </a:ln>
@@ -6153,7 +6200,7 @@
             <a:r>
               <a:rPr lang="en-US" sz="1600" b="1" dirty="0">
                 <a:solidFill>
-                  <a:srgbClr val="0E7C86"/>
+                  <a:srgbClr val="0E8A8A"/>
                 </a:solidFill>
                 <a:latin typeface="Arial" pitchFamily="34" charset="0"/>
                 <a:ea typeface="Arial" pitchFamily="34" charset="-122"/>
@@ -6167,7 +6214,7 @@
             <a:r>
               <a:rPr lang="en-US" sz="1600" dirty="0">
                 <a:solidFill>
-                  <a:srgbClr val="16333C"/>
+                  <a:srgbClr val="1C2547"/>
                 </a:solidFill>
                 <a:latin typeface="Arial" pitchFamily="34" charset="0"/>
                 <a:ea typeface="Arial" pitchFamily="34" charset="-122"/>
@@ -6226,7 +6273,7 @@
             <a:avLst/>
           </a:prstGeom>
           <a:solidFill>
-            <a:srgbClr val="0E7C86"/>
+            <a:srgbClr val="6258A6"/>
           </a:solidFill>
           <a:ln/>
         </p:spPr>
@@ -6297,7 +6344,7 @@
             <a:r>
               <a:rPr lang="ar-SA" altLang="en-US" sz="2900" b="1" dirty="0">
                 <a:solidFill>
-                  <a:srgbClr val="0B3B4C"/>
+                  <a:srgbClr val="273470"/>
                 </a:solidFill>
                 <a:latin typeface="Arial" pitchFamily="34" charset="0"/>
                 <a:ea typeface="Arial" pitchFamily="34" charset="-122"/>
@@ -6326,7 +6373,7 @@
             </a:avLst>
           </a:prstGeom>
           <a:solidFill>
-            <a:srgbClr val="02C39A"/>
+            <a:srgbClr val="33CC99"/>
           </a:solidFill>
           <a:ln/>
         </p:spPr>
@@ -6358,7 +6405,7 @@
             <a:r>
               <a:rPr lang="en-US" sz="1500" b="1" dirty="0">
                 <a:solidFill>
-                  <a:srgbClr val="0B3B4C"/>
+                  <a:srgbClr val="273470"/>
                 </a:solidFill>
                 <a:latin typeface="Arial" pitchFamily="34" charset="0"/>
                 <a:ea typeface="Arial" pitchFamily="34" charset="-122"/>
@@ -6387,7 +6434,7 @@
             </a:avLst>
           </a:prstGeom>
           <a:solidFill>
-            <a:srgbClr val="0E7C86"/>
+            <a:srgbClr val="0E8A8A"/>
           </a:solidFill>
           <a:ln/>
         </p:spPr>
@@ -6463,7 +6510,7 @@
             <a:avLst/>
           </a:prstGeom>
           <a:solidFill>
-            <a:srgbClr val="5B7176"/>
+            <a:srgbClr val="5A6285"/>
           </a:solidFill>
           <a:ln/>
         </p:spPr>
@@ -6485,7 +6532,7 @@
             </a:avLst>
           </a:prstGeom>
           <a:solidFill>
-            <a:srgbClr val="0B3B4C"/>
+            <a:srgbClr val="6258A6"/>
           </a:solidFill>
           <a:ln/>
         </p:spPr>
@@ -6561,7 +6608,7 @@
             <a:avLst/>
           </a:prstGeom>
           <a:solidFill>
-            <a:srgbClr val="5B7176"/>
+            <a:srgbClr val="5A6285"/>
           </a:solidFill>
           <a:ln/>
         </p:spPr>
@@ -6583,7 +6630,7 @@
             </a:avLst>
           </a:prstGeom>
           <a:solidFill>
-            <a:srgbClr val="0E7C86"/>
+            <a:srgbClr val="0E8A8A"/>
           </a:solidFill>
           <a:ln/>
         </p:spPr>
@@ -6659,7 +6706,7 @@
             <a:avLst/>
           </a:prstGeom>
           <a:solidFill>
-            <a:srgbClr val="5B7176"/>
+            <a:srgbClr val="5A6285"/>
           </a:solidFill>
           <a:ln/>
         </p:spPr>
@@ -6681,7 +6728,7 @@
             </a:avLst>
           </a:prstGeom>
           <a:solidFill>
-            <a:srgbClr val="0B3B4C"/>
+            <a:srgbClr val="6258A6"/>
           </a:solidFill>
           <a:ln/>
         </p:spPr>
@@ -6757,7 +6804,7 @@
             <a:avLst/>
           </a:prstGeom>
           <a:solidFill>
-            <a:srgbClr val="5B7176"/>
+            <a:srgbClr val="5A6285"/>
           </a:solidFill>
           <a:ln/>
         </p:spPr>
@@ -6779,7 +6826,7 @@
             </a:avLst>
           </a:prstGeom>
           <a:solidFill>
-            <a:srgbClr val="02C39A"/>
+            <a:srgbClr val="33CC99"/>
           </a:solidFill>
           <a:ln/>
         </p:spPr>
@@ -6811,7 +6858,7 @@
             <a:r>
               <a:rPr lang="en-US" sz="1300" b="1" dirty="0">
                 <a:solidFill>
-                  <a:srgbClr val="0B3B4C"/>
+                  <a:srgbClr val="273470"/>
                 </a:solidFill>
                 <a:latin typeface="Arial" pitchFamily="34" charset="0"/>
                 <a:ea typeface="Arial" pitchFamily="34" charset="-122"/>
@@ -6828,7 +6875,7 @@
             <a:r>
               <a:rPr lang="en-US" sz="1000" dirty="0">
                 <a:solidFill>
-                  <a:srgbClr val="0B3B4C"/>
+                  <a:srgbClr val="273470"/>
                 </a:solidFill>
                 <a:latin typeface="Arial" pitchFamily="34" charset="0"/>
                 <a:ea typeface="Arial" pitchFamily="34" charset="-122"/>
@@ -6857,7 +6904,7 @@
             </a:avLst>
           </a:prstGeom>
           <a:solidFill>
-            <a:srgbClr val="0B3B4C"/>
+            <a:srgbClr val="273470"/>
           </a:solidFill>
           <a:ln/>
         </p:spPr>
@@ -6892,7 +6939,7 @@
             <a:r>
               <a:rPr lang="en-US" sz="1400" dirty="0">
                 <a:solidFill>
-                  <a:srgbClr val="8FD8C7"/>
+                  <a:srgbClr val="7EE0C0"/>
                 </a:solidFill>
                 <a:latin typeface="Courier New" pitchFamily="34" charset="0"/>
                 <a:ea typeface="Courier New" pitchFamily="34" charset="-122"/>
@@ -6963,7 +7010,7 @@
             <a:r>
               <a:rPr lang="en-US" sz="1400" dirty="0">
                 <a:solidFill>
-                  <a:srgbClr val="9BC7C0"/>
+                  <a:srgbClr val="B9C0E4"/>
                 </a:solidFill>
                 <a:latin typeface="Courier New" pitchFamily="34" charset="0"/>
                 <a:ea typeface="Courier New" pitchFamily="34" charset="-122"/>
@@ -6980,7 +7027,7 @@
             <a:r>
               <a:rPr lang="en-US" sz="1400" b="1" dirty="0">
                 <a:solidFill>
-                  <a:srgbClr val="8FD8C7"/>
+                  <a:srgbClr val="7EE0C0"/>
                 </a:solidFill>
                 <a:latin typeface="Courier New" pitchFamily="34" charset="0"/>
                 <a:ea typeface="Courier New" pitchFamily="34" charset="-122"/>
@@ -7060,11 +7107,11 @@
             </a:avLst>
           </a:prstGeom>
           <a:solidFill>
-            <a:srgbClr val="E2F3EE"/>
+            <a:srgbClr val="E6F7F1"/>
           </a:solidFill>
           <a:ln w="12700">
             <a:solidFill>
-              <a:srgbClr val="02C39A"/>
+              <a:srgbClr val="33CC99"/>
             </a:solidFill>
             <a:prstDash val="solid"/>
           </a:ln>
@@ -7097,7 +7144,7 @@
             <a:r>
               <a:rPr lang="en-US" sz="1600" b="1" dirty="0">
                 <a:solidFill>
-                  <a:srgbClr val="0E7C86"/>
+                  <a:srgbClr val="0E8A8A"/>
                 </a:solidFill>
                 <a:latin typeface="Arial" pitchFamily="34" charset="0"/>
                 <a:ea typeface="Arial" pitchFamily="34" charset="-122"/>
@@ -7111,7 +7158,7 @@
             <a:r>
               <a:rPr lang="en-US" sz="1600" dirty="0">
                 <a:solidFill>
-                  <a:srgbClr val="16333C"/>
+                  <a:srgbClr val="1C2547"/>
                 </a:solidFill>
                 <a:latin typeface="Arial" pitchFamily="34" charset="0"/>
                 <a:ea typeface="Arial" pitchFamily="34" charset="-122"/>
@@ -7170,7 +7217,7 @@
             <a:avLst/>
           </a:prstGeom>
           <a:solidFill>
-            <a:srgbClr val="0E7C86"/>
+            <a:srgbClr val="6258A6"/>
           </a:solidFill>
           <a:ln/>
         </p:spPr>
@@ -7241,7 +7288,7 @@
             <a:r>
               <a:rPr lang="ar-SA" altLang="en-US" sz="2900" b="1" dirty="0">
                 <a:solidFill>
-                  <a:srgbClr val="0B3B4C"/>
+                  <a:srgbClr val="273470"/>
                 </a:solidFill>
                 <a:latin typeface="Arial" pitchFamily="34" charset="0"/>
                 <a:ea typeface="Arial" pitchFamily="34" charset="-122"/>
@@ -7270,7 +7317,7 @@
             </a:avLst>
           </a:prstGeom>
           <a:solidFill>
-            <a:srgbClr val="02C39A"/>
+            <a:srgbClr val="33CC99"/>
           </a:solidFill>
           <a:ln/>
         </p:spPr>
@@ -7302,7 +7349,7 @@
             <a:r>
               <a:rPr lang="en-US" sz="1500" b="1" dirty="0">
                 <a:solidFill>
-                  <a:srgbClr val="0B3B4C"/>
+                  <a:srgbClr val="273470"/>
                 </a:solidFill>
                 <a:latin typeface="Arial" pitchFamily="34" charset="0"/>
                 <a:ea typeface="Arial" pitchFamily="34" charset="-122"/>
@@ -7345,7 +7392,7 @@
             <a:r>
               <a:rPr lang="en-US" sz="1700" dirty="0">
                 <a:solidFill>
-                  <a:srgbClr val="16333C"/>
+                  <a:srgbClr val="1C2547"/>
                 </a:solidFill>
                 <a:latin typeface="Arial" pitchFamily="34" charset="0"/>
                 <a:ea typeface="Arial" pitchFamily="34" charset="-122"/>
@@ -7366,7 +7413,7 @@
             <a:r>
               <a:rPr lang="en-US" sz="1700" dirty="0">
                 <a:solidFill>
-                  <a:srgbClr val="16333C"/>
+                  <a:srgbClr val="1C2547"/>
                 </a:solidFill>
                 <a:latin typeface="Arial" pitchFamily="34" charset="0"/>
                 <a:ea typeface="Arial" pitchFamily="34" charset="-122"/>
@@ -7387,7 +7434,7 @@
             <a:r>
               <a:rPr lang="en-US" sz="1700" dirty="0">
                 <a:solidFill>
-                  <a:srgbClr val="16333C"/>
+                  <a:srgbClr val="1C2547"/>
                 </a:solidFill>
                 <a:latin typeface="Arial" pitchFamily="34" charset="0"/>
                 <a:ea typeface="Arial" pitchFamily="34" charset="-122"/>
@@ -7408,7 +7455,7 @@
             <a:r>
               <a:rPr lang="en-US" sz="1700" dirty="0">
                 <a:solidFill>
-                  <a:srgbClr val="16333C"/>
+                  <a:srgbClr val="1C2547"/>
                 </a:solidFill>
                 <a:latin typeface="Arial" pitchFamily="34" charset="0"/>
                 <a:ea typeface="Arial" pitchFamily="34" charset="-122"/>
@@ -7437,11 +7484,11 @@
             </a:avLst>
           </a:prstGeom>
           <a:solidFill>
-            <a:srgbClr val="F0F6F5"/>
+            <a:srgbClr val="F2F3FA"/>
           </a:solidFill>
           <a:ln w="9525">
             <a:solidFill>
-              <a:srgbClr val="CFE0DE"/>
+              <a:srgbClr val="D6DAEC"/>
             </a:solidFill>
             <a:prstDash val="solid"/>
           </a:ln>
@@ -7474,7 +7521,7 @@
             <a:r>
               <a:rPr lang="en-US" sz="1350" dirty="0">
                 <a:solidFill>
-                  <a:srgbClr val="16333C"/>
+                  <a:srgbClr val="1C2547"/>
                 </a:solidFill>
                 <a:latin typeface="Arial" pitchFamily="34" charset="0"/>
                 <a:ea typeface="Arial" pitchFamily="34" charset="-122"/>
@@ -7501,7 +7548,7 @@
             <a:avLst/>
           </a:prstGeom>
           <a:solidFill>
-            <a:srgbClr val="5B7176"/>
+            <a:srgbClr val="5A6285"/>
           </a:solidFill>
           <a:ln/>
         </p:spPr>
@@ -7523,11 +7570,11 @@
             </a:avLst>
           </a:prstGeom>
           <a:solidFill>
-            <a:srgbClr val="F0F6F5"/>
+            <a:srgbClr val="F2F3FA"/>
           </a:solidFill>
           <a:ln w="9525">
             <a:solidFill>
-              <a:srgbClr val="CFE0DE"/>
+              <a:srgbClr val="D6DAEC"/>
             </a:solidFill>
             <a:prstDash val="solid"/>
           </a:ln>
@@ -7560,7 +7607,7 @@
             <a:r>
               <a:rPr lang="en-US" sz="1350" dirty="0">
                 <a:solidFill>
-                  <a:srgbClr val="16333C"/>
+                  <a:srgbClr val="1C2547"/>
                 </a:solidFill>
                 <a:latin typeface="Arial" pitchFamily="34" charset="0"/>
                 <a:ea typeface="Arial" pitchFamily="34" charset="-122"/>
@@ -7587,7 +7634,7 @@
             <a:avLst/>
           </a:prstGeom>
           <a:solidFill>
-            <a:srgbClr val="5B7176"/>
+            <a:srgbClr val="5A6285"/>
           </a:solidFill>
           <a:ln/>
         </p:spPr>
@@ -7609,11 +7656,11 @@
             </a:avLst>
           </a:prstGeom>
           <a:solidFill>
-            <a:srgbClr val="F0F6F5"/>
+            <a:srgbClr val="F2F3FA"/>
           </a:solidFill>
           <a:ln w="9525">
             <a:solidFill>
-              <a:srgbClr val="CFE0DE"/>
+              <a:srgbClr val="D6DAEC"/>
             </a:solidFill>
             <a:prstDash val="solid"/>
           </a:ln>
@@ -7646,7 +7693,7 @@
             <a:r>
               <a:rPr lang="en-US" sz="1350" dirty="0">
                 <a:solidFill>
-                  <a:srgbClr val="16333C"/>
+                  <a:srgbClr val="1C2547"/>
                 </a:solidFill>
                 <a:latin typeface="Arial" pitchFamily="34" charset="0"/>
                 <a:ea typeface="Arial" pitchFamily="34" charset="-122"/>
@@ -7673,7 +7720,7 @@
             <a:avLst/>
           </a:prstGeom>
           <a:solidFill>
-            <a:srgbClr val="5B7176"/>
+            <a:srgbClr val="5A6285"/>
           </a:solidFill>
           <a:ln/>
         </p:spPr>
@@ -7695,11 +7742,11 @@
             </a:avLst>
           </a:prstGeom>
           <a:solidFill>
-            <a:srgbClr val="0B3B4C"/>
+            <a:srgbClr val="273470"/>
           </a:solidFill>
           <a:ln w="9525">
             <a:solidFill>
-              <a:srgbClr val="CFE0DE"/>
+              <a:srgbClr val="D6DAEC"/>
             </a:solidFill>
             <a:prstDash val="solid"/>
           </a:ln>
@@ -7765,7 +7812,7 @@
           </a:solidFill>
           <a:ln w="12700">
             <a:solidFill>
-              <a:srgbClr val="CFE0DE"/>
+              <a:srgbClr val="D6DAEC"/>
             </a:solidFill>
             <a:prstDash val="solid"/>
           </a:ln>
@@ -7822,7 +7869,7 @@
             <a:r>
               <a:rPr lang="en-US" sz="1250" dirty="0">
                 <a:solidFill>
-                  <a:srgbClr val="5B7176"/>
+                  <a:srgbClr val="5A6285"/>
                 </a:solidFill>
                 <a:latin typeface="Arial" pitchFamily="34" charset="0"/>
                 <a:ea typeface="Arial" pitchFamily="34" charset="-122"/>
@@ -7881,7 +7928,7 @@
             <a:avLst/>
           </a:prstGeom>
           <a:solidFill>
-            <a:srgbClr val="0E7C86"/>
+            <a:srgbClr val="6258A6"/>
           </a:solidFill>
           <a:ln/>
         </p:spPr>
@@ -7952,7 +7999,7 @@
             <a:r>
               <a:rPr lang="ar-SA" altLang="en-US" sz="2900" b="1" dirty="0">
                 <a:solidFill>
-                  <a:srgbClr val="0B3B4C"/>
+                  <a:srgbClr val="273470"/>
                 </a:solidFill>
                 <a:latin typeface="Arial" pitchFamily="34" charset="0"/>
                 <a:ea typeface="Arial" pitchFamily="34" charset="-122"/>
@@ -7981,7 +8028,7 @@
             </a:avLst>
           </a:prstGeom>
           <a:solidFill>
-            <a:srgbClr val="02C39A"/>
+            <a:srgbClr val="33CC99"/>
           </a:solidFill>
           <a:ln/>
         </p:spPr>
@@ -8013,7 +8060,7 @@
             <a:r>
               <a:rPr lang="en-US" sz="1500" b="1" dirty="0">
                 <a:solidFill>
-                  <a:srgbClr val="0B3B4C"/>
+                  <a:srgbClr val="273470"/>
                 </a:solidFill>
                 <a:latin typeface="Arial" pitchFamily="34" charset="0"/>
                 <a:ea typeface="Arial" pitchFamily="34" charset="-122"/>
@@ -8042,11 +8089,11 @@
             </a:avLst>
           </a:prstGeom>
           <a:solidFill>
-            <a:srgbClr val="F0F6F5"/>
+            <a:srgbClr val="F2F3FA"/>
           </a:solidFill>
           <a:ln w="15875">
             <a:solidFill>
-              <a:srgbClr val="0E7C86"/>
+              <a:srgbClr val="0E8A8A"/>
             </a:solidFill>
             <a:prstDash val="solid"/>
           </a:ln>
@@ -8079,7 +8126,7 @@
             <a:r>
               <a:rPr lang="en-US" sz="1900" b="1" dirty="0">
                 <a:solidFill>
-                  <a:srgbClr val="0E7C86"/>
+                  <a:srgbClr val="0E8A8A"/>
                 </a:solidFill>
                 <a:latin typeface="Arial" pitchFamily="34" charset="0"/>
                 <a:ea typeface="Arial" pitchFamily="34" charset="-122"/>
@@ -8122,7 +8169,7 @@
             <a:r>
               <a:rPr lang="en-US" sz="1500" dirty="0">
                 <a:solidFill>
-                  <a:srgbClr val="16333C"/>
+                  <a:srgbClr val="1C2547"/>
                 </a:solidFill>
                 <a:latin typeface="Arial" pitchFamily="34" charset="0"/>
                 <a:ea typeface="Arial" pitchFamily="34" charset="-122"/>
@@ -8140,7 +8187,7 @@
             <a:r>
               <a:rPr lang="en-US" sz="1500" dirty="0">
                 <a:solidFill>
-                  <a:srgbClr val="16333C"/>
+                  <a:srgbClr val="1C2547"/>
                 </a:solidFill>
                 <a:latin typeface="Arial" pitchFamily="34" charset="0"/>
                 <a:ea typeface="Arial" pitchFamily="34" charset="-122"/>
@@ -8169,7 +8216,7 @@
             </a:avLst>
           </a:prstGeom>
           <a:solidFill>
-            <a:srgbClr val="F0F6F5"/>
+            <a:srgbClr val="F2F3FA"/>
           </a:solidFill>
           <a:ln w="15875">
             <a:solidFill>
@@ -8249,7 +8296,7 @@
             <a:r>
               <a:rPr lang="en-US" sz="1500" dirty="0">
                 <a:solidFill>
-                  <a:srgbClr val="16333C"/>
+                  <a:srgbClr val="1C2547"/>
                 </a:solidFill>
                 <a:latin typeface="Arial" pitchFamily="34" charset="0"/>
                 <a:ea typeface="Arial" pitchFamily="34" charset="-122"/>
@@ -8267,7 +8314,7 @@
             <a:r>
               <a:rPr lang="en-US" sz="1500" dirty="0">
                 <a:solidFill>
-                  <a:srgbClr val="16333C"/>
+                  <a:srgbClr val="1C2547"/>
                 </a:solidFill>
                 <a:latin typeface="Arial" pitchFamily="34" charset="0"/>
                 <a:ea typeface="Arial" pitchFamily="34" charset="-122"/>
@@ -8296,7 +8343,7 @@
             </a:avLst>
           </a:prstGeom>
           <a:solidFill>
-            <a:srgbClr val="0B3B4C"/>
+            <a:srgbClr val="273470"/>
           </a:solidFill>
           <a:ln/>
         </p:spPr>
@@ -8328,7 +8375,7 @@
             <a:r>
               <a:rPr lang="en-US" sz="1800" b="1" dirty="0">
                 <a:solidFill>
-                  <a:srgbClr val="02C39A"/>
+                  <a:srgbClr val="33CC99"/>
                 </a:solidFill>
                 <a:latin typeface="Arial" pitchFamily="34" charset="0"/>
                 <a:ea typeface="Arial" pitchFamily="34" charset="-122"/>
@@ -8371,11 +8418,11 @@
             </a:avLst>
           </a:prstGeom>
           <a:solidFill>
-            <a:srgbClr val="E2F3EE"/>
+            <a:srgbClr val="E6F7F1"/>
           </a:solidFill>
           <a:ln w="12700">
             <a:solidFill>
-              <a:srgbClr val="02C39A"/>
+              <a:srgbClr val="33CC99"/>
             </a:solidFill>
             <a:prstDash val="solid"/>
           </a:ln>
@@ -8408,7 +8455,7 @@
             <a:r>
               <a:rPr lang="en-US" sz="1600" b="1" dirty="0">
                 <a:solidFill>
-                  <a:srgbClr val="0E7C86"/>
+                  <a:srgbClr val="0E8A8A"/>
                 </a:solidFill>
                 <a:latin typeface="Arial" pitchFamily="34" charset="0"/>
                 <a:ea typeface="Arial" pitchFamily="34" charset="-122"/>
@@ -8422,7 +8469,7 @@
             <a:r>
               <a:rPr lang="en-US" sz="1600" dirty="0">
                 <a:solidFill>
-                  <a:srgbClr val="16333C"/>
+                  <a:srgbClr val="1C2547"/>
                 </a:solidFill>
                 <a:latin typeface="Arial" pitchFamily="34" charset="0"/>
                 <a:ea typeface="Arial" pitchFamily="34" charset="-122"/>
@@ -8448,7 +8495,7 @@
     <p:bg>
       <p:bgPr>
         <a:solidFill>
-          <a:srgbClr val="0B3B4C"/>
+          <a:srgbClr val="273470"/>
         </a:solidFill>
       </p:bgPr>
     </p:bg>
@@ -8522,11 +8569,11 @@
             </a:avLst>
           </a:prstGeom>
           <a:solidFill>
-            <a:srgbClr val="10505F"/>
+            <a:srgbClr val="333F82"/>
           </a:solidFill>
           <a:ln w="9525">
             <a:solidFill>
-              <a:srgbClr val="1E6B76"/>
+              <a:srgbClr val="4A55A0"/>
             </a:solidFill>
             <a:prstDash val="solid"/>
           </a:ln>
@@ -8547,11 +8594,11 @@
             <a:avLst/>
           </a:prstGeom>
           <a:solidFill>
-            <a:srgbClr val="02C39A"/>
+            <a:srgbClr val="33CC99"/>
           </a:solidFill>
           <a:ln w="19050">
             <a:solidFill>
-              <a:srgbClr val="0B3B4C"/>
+              <a:srgbClr val="273470"/>
             </a:solidFill>
             <a:prstDash val="solid"/>
           </a:ln>
@@ -8584,7 +8631,7 @@
             <a:r>
               <a:rPr lang="en-US" sz="1800" b="1" dirty="0">
                 <a:solidFill>
-                  <a:srgbClr val="0B3B4C"/>
+                  <a:srgbClr val="273470"/>
                 </a:solidFill>
                 <a:latin typeface="Arial" pitchFamily="34" charset="0"/>
                 <a:ea typeface="Arial" pitchFamily="34" charset="-122"/>
@@ -8662,7 +8709,7 @@
             <a:r>
               <a:rPr lang="en-US" sz="1300" dirty="0">
                 <a:solidFill>
-                  <a:srgbClr val="9BC7C0"/>
+                  <a:srgbClr val="B9C0E4"/>
                 </a:solidFill>
                 <a:latin typeface="Arial" pitchFamily="34" charset="0"/>
                 <a:ea typeface="Arial" pitchFamily="34" charset="-122"/>
@@ -8691,11 +8738,11 @@
             </a:avLst>
           </a:prstGeom>
           <a:solidFill>
-            <a:srgbClr val="10505F"/>
+            <a:srgbClr val="333F82"/>
           </a:solidFill>
           <a:ln w="9525">
             <a:solidFill>
-              <a:srgbClr val="1E6B76"/>
+              <a:srgbClr val="4A55A0"/>
             </a:solidFill>
             <a:prstDash val="solid"/>
           </a:ln>
@@ -8720,7 +8767,7 @@
           </a:solidFill>
           <a:ln w="19050">
             <a:solidFill>
-              <a:srgbClr val="0B3B4C"/>
+              <a:srgbClr val="273470"/>
             </a:solidFill>
             <a:prstDash val="solid"/>
           </a:ln>
@@ -8831,7 +8878,7 @@
             <a:r>
               <a:rPr lang="en-US" sz="1300" dirty="0">
                 <a:solidFill>
-                  <a:srgbClr val="9BC7C0"/>
+                  <a:srgbClr val="B9C0E4"/>
                 </a:solidFill>
                 <a:latin typeface="Arial" pitchFamily="34" charset="0"/>
                 <a:ea typeface="Arial" pitchFamily="34" charset="-122"/>
@@ -8860,11 +8907,11 @@
             </a:avLst>
           </a:prstGeom>
           <a:solidFill>
-            <a:srgbClr val="10505F"/>
+            <a:srgbClr val="333F82"/>
           </a:solidFill>
           <a:ln w="9525">
             <a:solidFill>
-              <a:srgbClr val="1E6B76"/>
+              <a:srgbClr val="4A55A0"/>
             </a:solidFill>
             <a:prstDash val="solid"/>
           </a:ln>
@@ -8885,11 +8932,11 @@
             <a:avLst/>
           </a:prstGeom>
           <a:solidFill>
-            <a:srgbClr val="02C39A"/>
+            <a:srgbClr val="33CC99"/>
           </a:solidFill>
           <a:ln w="19050">
             <a:solidFill>
-              <a:srgbClr val="0B3B4C"/>
+              <a:srgbClr val="273470"/>
             </a:solidFill>
             <a:prstDash val="solid"/>
           </a:ln>
@@ -8922,7 +8969,7 @@
             <a:r>
               <a:rPr lang="en-US" sz="1800" b="1" dirty="0">
                 <a:solidFill>
-                  <a:srgbClr val="0B3B4C"/>
+                  <a:srgbClr val="273470"/>
                 </a:solidFill>
                 <a:latin typeface="Arial" pitchFamily="34" charset="0"/>
                 <a:ea typeface="Arial" pitchFamily="34" charset="-122"/>
@@ -9000,7 +9047,7 @@
             <a:r>
               <a:rPr lang="en-US" sz="1300" dirty="0">
                 <a:solidFill>
-                  <a:srgbClr val="9BC7C0"/>
+                  <a:srgbClr val="B9C0E4"/>
                 </a:solidFill>
                 <a:latin typeface="Arial" pitchFamily="34" charset="0"/>
                 <a:ea typeface="Arial" pitchFamily="34" charset="-122"/>
@@ -9029,11 +9076,11 @@
             </a:avLst>
           </a:prstGeom>
           <a:solidFill>
-            <a:srgbClr val="10505F"/>
+            <a:srgbClr val="333F82"/>
           </a:solidFill>
           <a:ln w="9525">
             <a:solidFill>
-              <a:srgbClr val="1E6B76"/>
+              <a:srgbClr val="4A55A0"/>
             </a:solidFill>
             <a:prstDash val="solid"/>
           </a:ln>
@@ -9054,11 +9101,11 @@
             <a:avLst/>
           </a:prstGeom>
           <a:solidFill>
-            <a:srgbClr val="02C39A"/>
+            <a:srgbClr val="33CC99"/>
           </a:solidFill>
           <a:ln w="19050">
             <a:solidFill>
-              <a:srgbClr val="0B3B4C"/>
+              <a:srgbClr val="273470"/>
             </a:solidFill>
             <a:prstDash val="solid"/>
           </a:ln>
@@ -9091,7 +9138,7 @@
             <a:r>
               <a:rPr lang="en-US" sz="1800" b="1" dirty="0">
                 <a:solidFill>
-                  <a:srgbClr val="0B3B4C"/>
+                  <a:srgbClr val="273470"/>
                 </a:solidFill>
                 <a:latin typeface="Arial" pitchFamily="34" charset="0"/>
                 <a:ea typeface="Arial" pitchFamily="34" charset="-122"/>
@@ -9169,7 +9216,7 @@
             <a:r>
               <a:rPr lang="en-US" sz="1300" dirty="0">
                 <a:solidFill>
-                  <a:srgbClr val="9BC7C0"/>
+                  <a:srgbClr val="B9C0E4"/>
                 </a:solidFill>
                 <a:latin typeface="Arial" pitchFamily="34" charset="0"/>
                 <a:ea typeface="Arial" pitchFamily="34" charset="-122"/>
@@ -9297,11 +9344,11 @@
             </a:avLst>
           </a:prstGeom>
           <a:solidFill>
-            <a:srgbClr val="10505F"/>
+            <a:srgbClr val="333F82"/>
           </a:solidFill>
           <a:ln w="12700">
             <a:solidFill>
-              <a:srgbClr val="02C39A"/>
+              <a:srgbClr val="33CC99"/>
             </a:solidFill>
             <a:prstDash val="solid"/>
           </a:ln>
@@ -9334,7 +9381,7 @@
             <a:r>
               <a:rPr lang="en-US" sz="1500" b="1" dirty="0">
                 <a:solidFill>
-                  <a:srgbClr val="02C39A"/>
+                  <a:srgbClr val="33CC99"/>
                 </a:solidFill>
                 <a:latin typeface="Arial" pitchFamily="34" charset="0"/>
                 <a:ea typeface="Arial" pitchFamily="34" charset="-122"/>

</xml_diff>

<commit_message>
Add repo QR code to the deck (closing slide + title corner)
1.8 inch QR on a white plate beside the repo URL on slide 11, plus a 0.85 inch corner version on slide 1 so it is scannable from the start. Square dimensions verified in EMU; both slides re-exported and inspected. Co-Authored-By: Claude Fable 5 <noreply@anthropic.com>
</commit_message>
<xml_diff>
--- a/docs/presentation.pptx
+++ b/docs/presentation.pptx
@@ -2428,6 +2428,76 @@
           </a:p>
         </p:txBody>
       </p:sp>
+      <p:sp>
+        <p:nvSpPr>
+          <p:cNvPr id="21" name="Rounded Rectangle 20"/>
+          <p:cNvSpPr/>
+          <p:nvPr/>
+        </p:nvSpPr>
+        <p:spPr>
+          <a:xfrm>
+            <a:off x="10545775" y="5486400"/>
+            <a:ext cx="914400" cy="914400"/>
+          </a:xfrm>
+          <a:prstGeom prst="roundRect">
+            <a:avLst>
+              <a:gd name="adj" fmla="val 8000"/>
+            </a:avLst>
+          </a:prstGeom>
+          <a:solidFill>
+            <a:srgbClr val="FFFFFF"/>
+          </a:solidFill>
+          <a:ln>
+            <a:noFill/>
+          </a:ln>
+          <a:effectLst/>
+        </p:spPr>
+        <p:style>
+          <a:lnRef idx="1">
+            <a:schemeClr val="accent1"/>
+          </a:lnRef>
+          <a:fillRef idx="3">
+            <a:schemeClr val="accent1"/>
+          </a:fillRef>
+          <a:effectRef idx="2">
+            <a:schemeClr val="accent1"/>
+          </a:effectRef>
+          <a:fontRef idx="minor">
+            <a:schemeClr val="lt1"/>
+          </a:fontRef>
+        </p:style>
+        <p:txBody>
+          <a:bodyPr rtlCol="0" anchor="ctr"/>
+          <a:lstStyle/>
+          <a:p>
+            <a:pPr algn="ctr"/>
+          </a:p>
+        </p:txBody>
+      </p:sp>
+      <p:pic>
+        <p:nvPicPr>
+          <p:cNvPr id="22" name="Picture 21" descr="repo_qr.png"/>
+          <p:cNvPicPr>
+            <a:picLocks noChangeAspect="1"/>
+          </p:cNvPicPr>
+          <p:nvPr/>
+        </p:nvPicPr>
+        <p:blipFill>
+          <a:blip r:embed="rId4"/>
+          <a:stretch>
+            <a:fillRect/>
+          </a:stretch>
+        </p:blipFill>
+        <p:spPr>
+          <a:xfrm>
+            <a:off x="10614355" y="5554980"/>
+            <a:ext cx="777240" cy="777240"/>
+          </a:xfrm>
+          <a:prstGeom prst="rect">
+            <a:avLst/>
+          </a:prstGeom>
+        </p:spPr>
+      </p:pic>
     </p:spTree>
   </p:cSld>
   <p:clrMapOvr>
@@ -3260,6 +3330,111 @@
               <a:t>SDAIA Academy · Modern Data Engineering for AI Systems · 2026</a:t>
             </a:r>
             <a:endParaRPr lang="en-US" sz="1200" dirty="0"/>
+          </a:p>
+        </p:txBody>
+      </p:sp>
+      <p:sp>
+        <p:nvSpPr>
+          <p:cNvPr id="8" name="Rounded Rectangle 7"/>
+          <p:cNvSpPr/>
+          <p:nvPr/>
+        </p:nvSpPr>
+        <p:spPr>
+          <a:xfrm>
+            <a:off x="9631375" y="3177540"/>
+            <a:ext cx="1828800" cy="1828800"/>
+          </a:xfrm>
+          <a:prstGeom prst="roundRect">
+            <a:avLst>
+              <a:gd name="adj" fmla="val 8000"/>
+            </a:avLst>
+          </a:prstGeom>
+          <a:solidFill>
+            <a:srgbClr val="FFFFFF"/>
+          </a:solidFill>
+          <a:ln>
+            <a:noFill/>
+          </a:ln>
+          <a:effectLst/>
+        </p:spPr>
+        <p:style>
+          <a:lnRef idx="1">
+            <a:schemeClr val="accent1"/>
+          </a:lnRef>
+          <a:fillRef idx="3">
+            <a:schemeClr val="accent1"/>
+          </a:fillRef>
+          <a:effectRef idx="2">
+            <a:schemeClr val="accent1"/>
+          </a:effectRef>
+          <a:fontRef idx="minor">
+            <a:schemeClr val="lt1"/>
+          </a:fontRef>
+        </p:style>
+        <p:txBody>
+          <a:bodyPr rtlCol="0" anchor="ctr"/>
+          <a:lstStyle/>
+          <a:p>
+            <a:pPr algn="ctr"/>
+          </a:p>
+        </p:txBody>
+      </p:sp>
+      <p:pic>
+        <p:nvPicPr>
+          <p:cNvPr id="9" name="Picture 8" descr="repo_qr.png"/>
+          <p:cNvPicPr>
+            <a:picLocks noChangeAspect="1"/>
+          </p:cNvPicPr>
+          <p:nvPr/>
+        </p:nvPicPr>
+        <p:blipFill>
+          <a:blip r:embed="rId3"/>
+          <a:stretch>
+            <a:fillRect/>
+          </a:stretch>
+        </p:blipFill>
+        <p:spPr>
+          <a:xfrm>
+            <a:off x="9722815" y="3268980"/>
+            <a:ext cx="1645920" cy="1645920"/>
+          </a:xfrm>
+          <a:prstGeom prst="rect">
+            <a:avLst/>
+          </a:prstGeom>
+        </p:spPr>
+      </p:pic>
+      <p:sp>
+        <p:nvSpPr>
+          <p:cNvPr id="10" name="TextBox 9"/>
+          <p:cNvSpPr txBox="1"/>
+          <p:nvPr/>
+        </p:nvSpPr>
+        <p:spPr>
+          <a:xfrm>
+            <a:off x="9494215" y="5079492"/>
+            <a:ext cx="2103120" cy="457200"/>
+          </a:xfrm>
+          <a:prstGeom prst="rect">
+            <a:avLst/>
+          </a:prstGeom>
+          <a:noFill/>
+        </p:spPr>
+        <p:txBody>
+          <a:bodyPr wrap="square" lIns="0" rIns="0" tIns="0" bIns="0">
+            <a:spAutoFit/>
+          </a:bodyPr>
+          <a:lstStyle/>
+          <a:p>
+            <a:pPr algn="ctr" rtl="1"/>
+            <a:r>
+              <a:rPr sz="1200" b="0">
+                <a:solidFill>
+                  <a:srgbClr val="B9C0E4"/>
+                </a:solidFill>
+                <a:latin typeface="Arial"/>
+              </a:rPr>
+              <a:t>امسح للمستودع ‏·‏ scan for the repo</a:t>
+            </a:r>
           </a:p>
         </p:txBody>
       </p:sp>

</xml_diff>